<commit_message>
Pitch deck: "What we did about it" slide mirroring the problem slide
Generated with [Devin](https://devin.ai)

Co-Authored-By: Devin <158243242+devin-ai-integration[bot]@users.noreply.github.com>
</commit_message>
<xml_diff>
--- a/docs/slides/pitch.pptx
+++ b/docs/slides/pitch.pptx
@@ -11,6 +11,7 @@
     <p:sldId id="259" r:id="rId11"/>
     <p:sldId id="260" r:id="rId12"/>
     <p:sldId id="261" r:id="rId13"/>
+    <p:sldId id="262" r:id="rId14"/>
   </p:sldIdLst>
   <p:sldSz cx="12191695" cy="6858000" type="screen4x3"/>
   <p:notesSz cx="6858000" cy="9144000"/>
@@ -647,7 +648,7 @@
           <a:lstStyle/>
           <a:p>
             <a:r>
-              <a:t>A request in any EU language is translated once. An AI picks the matching rule from the actual law text and quotes it. Prohibited purposes are rejected with the quote. Approved requests are parsed by rules into SQL; statistics go through the small-cell rule, record requests are copied into a secure room with no download. Anyone flooding the service is blocked. (≈20 s)</a:t>
+              <a:t>So what did we do about it? Researchers write the request in plain words, in any EU language, and if they cannot phrase the definitions, one click drafts them. Engineers are out of the loop: fixed rules turn the definitions into SQL, and an AI only steps in where the rules give up, under the same checks. And the access body gets a decision that quotes the article from the regulation, with the privacy rules enforced inside the query and records locked in a secure room. Seconds instead of weeks, and the same answer every time. (≈25 s)</a:t>
             </a:r>
           </a:p>
         </p:txBody>
@@ -717,7 +718,7 @@
           <a:lstStyle/>
           <a:p>
             <a:r>
-              <a:t>Why is this better than a black box? There is no technical burden: the applicant writes in plain words and the AI even drafts the definitions. Every decision quotes the article verbatim, so it is explainable. The numbers come from code, not from the AI, so they are the same every run. Privacy rules are enforced inside the query, and everything is logged. (≈20 s)</a:t>
+              <a:t>A request in any EU language is translated once. An AI picks the matching rule from the actual law text and quotes it. Prohibited purposes are rejected with the quote. Approved requests are parsed by rules into SQL; statistics go through the small-cell rule, record requests are copied into a secure room with no download. Anyone flooding the service is blocked. (≈20 s)</a:t>
             </a:r>
           </a:p>
         </p:txBody>
@@ -787,32 +788,7 @@
           <a:lstStyle/>
           <a:p>
             <a:r>
-              <a:t>Now the demo, in four steps and one attack. (switch to screen capture; ≈50 s)</a:t>
-            </a:r>
-          </a:p>
-          <a:p>
-            <a:r>
-              <a:t>R02: the insurer. Submit. Rejected, Art. 54(b), quoted.</a:t>
-            </a:r>
-          </a:p>
-          <a:p>
-            <a:r>
-              <a:t>R01: diabetes by region. Submit. The table, with the small-cell note.</a:t>
-            </a:r>
-          </a:p>
-          <a:p>
-            <a:r>
-              <a:t>R11: the same request in German. The decision shows the English text next to it.</a:t>
-            </a:r>
-          </a:p>
-          <a:p>
-            <a:r>
-              <a:t>R12: records for a prediction model. Approved into the secure room; open it, browse; click Download: 403, logged.</a:t>
-            </a:r>
-          </a:p>
-          <a:p>
-            <a:r>
-              <a:t>Finally run flood.py in a terminal: 20 served, then 429 with Retry-After.</a:t>
+              <a:t>Why is this better than a black box? There is no technical burden: the applicant writes in plain words and the AI even drafts the definitions. Every decision quotes the article verbatim, so it is explainable. The numbers come from code, not from the AI, so they are the same every run. Privacy rules are enforced inside the query, and everything is logged. (≈20 s)</a:t>
             </a:r>
           </a:p>
         </p:txBody>
@@ -838,6 +814,101 @@
 </file>
 
 <file path=ppt/notesSlides/notesSlide6.xml><?xml version="1.0" encoding="utf-8"?>
+<p:notes xmlns:a="http://schemas.openxmlformats.org/drawingml/2006/main" xmlns:p="http://schemas.openxmlformats.org/presentationml/2006/main" xmlns:r="http://schemas.openxmlformats.org/officeDocument/2006/relationships">
+  <p:cSld>
+    <p:spTree>
+      <p:nvGrpSpPr>
+        <p:cNvPr id="1" name=""/>
+        <p:cNvGrpSpPr/>
+        <p:nvPr/>
+      </p:nvGrpSpPr>
+      <p:grpSpPr>
+        <a:xfrm>
+          <a:off x="0" y="0"/>
+          <a:ext cx="0" cy="0"/>
+          <a:chOff x="0" y="0"/>
+          <a:chExt cx="0" cy="0"/>
+        </a:xfrm>
+      </p:grpSpPr>
+      <p:sp>
+        <p:nvSpPr>
+          <p:cNvPr id="2" name="Slide Image Placeholder 1"/>
+          <p:cNvSpPr>
+            <a:spLocks noGrp="1"/>
+          </p:cNvSpPr>
+          <p:nvPr>
+            <p:ph type="sldImg" idx="2"/>
+          </p:nvPr>
+        </p:nvSpPr>
+        <p:spPr/>
+      </p:sp>
+      <p:sp>
+        <p:nvSpPr>
+          <p:cNvPr id="3" name="Notes Placeholder 2"/>
+          <p:cNvSpPr>
+            <a:spLocks noGrp="1"/>
+          </p:cNvSpPr>
+          <p:nvPr>
+            <p:ph type="body" idx="3" sz="quarter"/>
+          </p:nvPr>
+        </p:nvSpPr>
+        <p:spPr/>
+        <p:txBody>
+          <a:bodyPr/>
+          <a:lstStyle/>
+          <a:p>
+            <a:r>
+              <a:t>Now the demo, in four steps and one attack. (switch to screen capture; ≈50 s)</a:t>
+            </a:r>
+          </a:p>
+          <a:p>
+            <a:r>
+              <a:t>R02: the insurer. Submit. Rejected, Art. 54(b), quoted.</a:t>
+            </a:r>
+          </a:p>
+          <a:p>
+            <a:r>
+              <a:t>R01: diabetes by region. Submit. The table, with the small-cell note.</a:t>
+            </a:r>
+          </a:p>
+          <a:p>
+            <a:r>
+              <a:t>R11: the same request in German. The decision shows the English text next to it.</a:t>
+            </a:r>
+          </a:p>
+          <a:p>
+            <a:r>
+              <a:t>R12: records for a prediction model. Approved into the secure room; open it, browse; click Download: 403, logged.</a:t>
+            </a:r>
+          </a:p>
+          <a:p>
+            <a:r>
+              <a:t>Finally run flood.py in a terminal: 20 served, then 429 with Retry-After.</a:t>
+            </a:r>
+          </a:p>
+        </p:txBody>
+      </p:sp>
+      <p:sp>
+        <p:nvSpPr>
+          <p:cNvPr id="4" name="Slide Number Placeholder 3"/>
+          <p:cNvSpPr>
+            <a:spLocks noGrp="1"/>
+          </p:cNvSpPr>
+          <p:nvPr>
+            <p:ph type="sldNum" idx="5" sz="quarter"/>
+          </p:nvPr>
+        </p:nvSpPr>
+        <p:spPr/>
+      </p:sp>
+    </p:spTree>
+  </p:cSld>
+  <p:clrMapOvr>
+    <a:masterClrMapping/>
+  </p:clrMapOvr>
+</p:notes>
+</file>
+
+<file path=ppt/notesSlides/notesSlide7.xml><?xml version="1.0" encoding="utf-8"?>
 <p:notes xmlns:a="http://schemas.openxmlformats.org/drawingml/2006/main" xmlns:p="http://schemas.openxmlformats.org/presentationml/2006/main" xmlns:r="http://schemas.openxmlformats.org/officeDocument/2006/relationships">
   <p:cSld>
     <p:spTree>
@@ -4874,7 +4945,7 @@
                 </a:solidFill>
                 <a:latin typeface="Inter"/>
               </a:rPr>
-              <a:t>What we built: one pipeline, three outcomes</a:t>
+              <a:t>What we did about it</a:t>
             </a:r>
           </a:p>
         </p:txBody>
@@ -4909,7 +4980,7 @@
                 </a:solidFill>
                 <a:latin typeface="Inter"/>
               </a:rPr>
-              <a:t>request → law check → statistics or secure room; attackers blocked</a:t>
+              <a:t>the same three people, one app</a:t>
             </a:r>
           </a:p>
         </p:txBody>
@@ -4949,33 +5020,552 @@
           </a:p>
         </p:txBody>
       </p:sp>
-      <p:pic>
-        <p:nvPicPr>
-          <p:cNvPr id="6" name="Picture 5" descr="how-it-works.png"/>
-          <p:cNvPicPr>
-            <a:picLocks noChangeAspect="1"/>
-          </p:cNvPicPr>
-          <p:nvPr/>
-        </p:nvPicPr>
-        <p:blipFill>
-          <a:blip r:embed="rId2"/>
-          <a:stretch>
-            <a:fillRect/>
-          </a:stretch>
-        </p:blipFill>
-        <p:spPr>
-          <a:xfrm>
-            <a:off x="365760" y="1218111"/>
-            <a:ext cx="11430000" cy="5061857"/>
+      <p:sp>
+        <p:nvSpPr>
+          <p:cNvPr id="6" name="Rounded Rectangle 5"/>
+          <p:cNvSpPr/>
+          <p:nvPr/>
+        </p:nvSpPr>
+        <p:spPr>
+          <a:xfrm>
+            <a:off x="548640" y="1371600"/>
+            <a:ext cx="3474720" cy="3566160"/>
+          </a:xfrm>
+          <a:prstGeom prst="roundRect">
+            <a:avLst>
+              <a:gd name="adj" fmla="val 8000"/>
+            </a:avLst>
+          </a:prstGeom>
+          <a:solidFill>
+            <a:srgbClr val="F6F7F9"/>
+          </a:solidFill>
+          <a:ln w="19050">
+            <a:solidFill>
+              <a:srgbClr val="1565C0"/>
+            </a:solidFill>
+          </a:ln>
+          <a:effectLst/>
+        </p:spPr>
+        <p:style>
+          <a:lnRef idx="1">
+            <a:schemeClr val="accent1"/>
+          </a:lnRef>
+          <a:fillRef idx="3">
+            <a:schemeClr val="accent1"/>
+          </a:fillRef>
+          <a:effectRef idx="2">
+            <a:schemeClr val="accent1"/>
+          </a:effectRef>
+          <a:fontRef idx="minor">
+            <a:schemeClr val="lt1"/>
+          </a:fontRef>
+        </p:style>
+        <p:txBody>
+          <a:bodyPr rtlCol="0" anchor="ctr"/>
+          <a:lstStyle/>
+          <a:p>
+            <a:pPr algn="ctr"/>
+          </a:p>
+        </p:txBody>
+      </p:sp>
+      <p:sp>
+        <p:nvSpPr>
+          <p:cNvPr id="7" name="TextBox 6"/>
+          <p:cNvSpPr txBox="1"/>
+          <p:nvPr/>
+        </p:nvSpPr>
+        <p:spPr>
+          <a:xfrm>
+            <a:off x="777240" y="1554480"/>
+            <a:ext cx="3017520" cy="457200"/>
           </a:xfrm>
           <a:prstGeom prst="rect">
             <a:avLst/>
           </a:prstGeom>
-        </p:spPr>
-      </p:pic>
-      <p:sp>
-        <p:nvSpPr>
-          <p:cNvPr id="7" name="TextBox 6"/>
+          <a:noFill/>
+        </p:spPr>
+        <p:txBody>
+          <a:bodyPr wrap="square" anchor="t" lIns="45720" rIns="45720">
+            <a:spAutoFit/>
+          </a:bodyPr>
+          <a:lstStyle/>
+          <a:p>
+            <a:pPr algn="l"/>
+            <a:r>
+              <a:rPr sz="2000" b="1">
+                <a:solidFill>
+                  <a:srgbClr val="1565C0"/>
+                </a:solidFill>
+                <a:latin typeface="Inter"/>
+              </a:rPr>
+              <a:t>Researchers</a:t>
+            </a:r>
+          </a:p>
+        </p:txBody>
+      </p:sp>
+      <p:sp>
+        <p:nvSpPr>
+          <p:cNvPr id="8" name="TextBox 7"/>
+          <p:cNvSpPr txBox="1"/>
+          <p:nvPr/>
+        </p:nvSpPr>
+        <p:spPr>
+          <a:xfrm>
+            <a:off x="777240" y="2103120"/>
+            <a:ext cx="3017520" cy="2651760"/>
+          </a:xfrm>
+          <a:prstGeom prst="rect">
+            <a:avLst/>
+          </a:prstGeom>
+          <a:noFill/>
+        </p:spPr>
+        <p:txBody>
+          <a:bodyPr wrap="square">
+            <a:spAutoFit/>
+          </a:bodyPr>
+          <a:lstStyle/>
+          <a:p>
+            <a:pPr>
+              <a:spcAft>
+                <a:spcPts val="800"/>
+              </a:spcAft>
+            </a:pPr>
+            <a:r>
+              <a:rPr sz="1500" b="1">
+                <a:solidFill>
+                  <a:srgbClr val="1F2A37"/>
+                </a:solidFill>
+                <a:latin typeface="Inter"/>
+              </a:rPr>
+              <a:t>•  write the request in plain words, in any EU language</a:t>
+            </a:r>
+          </a:p>
+          <a:p>
+            <a:pPr>
+              <a:spcAft>
+                <a:spcPts val="800"/>
+              </a:spcAft>
+            </a:pPr>
+            <a:r>
+              <a:rPr sz="1500" b="1">
+                <a:solidFill>
+                  <a:srgbClr val="1F2A37"/>
+                </a:solidFill>
+                <a:latin typeface="Inter"/>
+              </a:rPr>
+              <a:t>•  one click: the AI drafts the definitions they could not phrase</a:t>
+            </a:r>
+          </a:p>
+          <a:p>
+            <a:pPr>
+              <a:spcAft>
+                <a:spcPts val="800"/>
+              </a:spcAft>
+            </a:pPr>
+            <a:r>
+              <a:rPr sz="1500" b="1">
+                <a:solidFill>
+                  <a:srgbClr val="1F2A37"/>
+                </a:solidFill>
+                <a:latin typeface="Inter"/>
+              </a:rPr>
+              <a:t>•  the answer comes back in seconds, with the reason</a:t>
+            </a:r>
+          </a:p>
+        </p:txBody>
+      </p:sp>
+      <p:sp>
+        <p:nvSpPr>
+          <p:cNvPr id="9" name="Rounded Rectangle 8"/>
+          <p:cNvSpPr/>
+          <p:nvPr/>
+        </p:nvSpPr>
+        <p:spPr>
+          <a:xfrm>
+            <a:off x="4343400" y="1371600"/>
+            <a:ext cx="3474720" cy="3566160"/>
+          </a:xfrm>
+          <a:prstGeom prst="roundRect">
+            <a:avLst>
+              <a:gd name="adj" fmla="val 8000"/>
+            </a:avLst>
+          </a:prstGeom>
+          <a:solidFill>
+            <a:srgbClr val="F6F7F9"/>
+          </a:solidFill>
+          <a:ln w="19050">
+            <a:solidFill>
+              <a:srgbClr val="F0B429"/>
+            </a:solidFill>
+          </a:ln>
+          <a:effectLst/>
+        </p:spPr>
+        <p:style>
+          <a:lnRef idx="1">
+            <a:schemeClr val="accent1"/>
+          </a:lnRef>
+          <a:fillRef idx="3">
+            <a:schemeClr val="accent1"/>
+          </a:fillRef>
+          <a:effectRef idx="2">
+            <a:schemeClr val="accent1"/>
+          </a:effectRef>
+          <a:fontRef idx="minor">
+            <a:schemeClr val="lt1"/>
+          </a:fontRef>
+        </p:style>
+        <p:txBody>
+          <a:bodyPr rtlCol="0" anchor="ctr"/>
+          <a:lstStyle/>
+          <a:p>
+            <a:pPr algn="ctr"/>
+          </a:p>
+        </p:txBody>
+      </p:sp>
+      <p:sp>
+        <p:nvSpPr>
+          <p:cNvPr id="10" name="TextBox 9"/>
+          <p:cNvSpPr txBox="1"/>
+          <p:nvPr/>
+        </p:nvSpPr>
+        <p:spPr>
+          <a:xfrm>
+            <a:off x="4572000" y="1554480"/>
+            <a:ext cx="3017520" cy="457200"/>
+          </a:xfrm>
+          <a:prstGeom prst="rect">
+            <a:avLst/>
+          </a:prstGeom>
+          <a:noFill/>
+        </p:spPr>
+        <p:txBody>
+          <a:bodyPr wrap="square" anchor="t" lIns="45720" rIns="45720">
+            <a:spAutoFit/>
+          </a:bodyPr>
+          <a:lstStyle/>
+          <a:p>
+            <a:pPr algn="l"/>
+            <a:r>
+              <a:rPr sz="2000" b="1">
+                <a:solidFill>
+                  <a:srgbClr val="F0B429"/>
+                </a:solidFill>
+                <a:latin typeface="Inter"/>
+              </a:rPr>
+              <a:t>Engineers</a:t>
+            </a:r>
+          </a:p>
+        </p:txBody>
+      </p:sp>
+      <p:sp>
+        <p:nvSpPr>
+          <p:cNvPr id="11" name="TextBox 10"/>
+          <p:cNvSpPr txBox="1"/>
+          <p:nvPr/>
+        </p:nvSpPr>
+        <p:spPr>
+          <a:xfrm>
+            <a:off x="4572000" y="2103120"/>
+            <a:ext cx="3017520" cy="2651760"/>
+          </a:xfrm>
+          <a:prstGeom prst="rect">
+            <a:avLst/>
+          </a:prstGeom>
+          <a:noFill/>
+        </p:spPr>
+        <p:txBody>
+          <a:bodyPr wrap="square">
+            <a:spAutoFit/>
+          </a:bodyPr>
+          <a:lstStyle/>
+          <a:p>
+            <a:pPr>
+              <a:spcAft>
+                <a:spcPts val="800"/>
+              </a:spcAft>
+            </a:pPr>
+            <a:r>
+              <a:rPr sz="1500" b="1">
+                <a:solidFill>
+                  <a:srgbClr val="1F2A37"/>
+                </a:solidFill>
+                <a:latin typeface="Inter"/>
+              </a:rPr>
+              <a:t>•  no one writes a query per request</a:t>
+            </a:r>
+          </a:p>
+          <a:p>
+            <a:pPr>
+              <a:spcAft>
+                <a:spcPts val="800"/>
+              </a:spcAft>
+            </a:pPr>
+            <a:r>
+              <a:rPr sz="1500" b="1">
+                <a:solidFill>
+                  <a:srgbClr val="1F2A37"/>
+                </a:solidFill>
+                <a:latin typeface="Inter"/>
+              </a:rPr>
+              <a:t>•  fixed rules turn the definitions into SQL; codes come from the request</a:t>
+            </a:r>
+          </a:p>
+          <a:p>
+            <a:pPr>
+              <a:spcAft>
+                <a:spcPts val="800"/>
+              </a:spcAft>
+            </a:pPr>
+            <a:r>
+              <a:rPr sz="1500" b="1">
+                <a:solidFill>
+                  <a:srgbClr val="1F2A37"/>
+                </a:solidFill>
+                <a:latin typeface="Inter"/>
+              </a:rPr>
+              <a:t>•  an LLM steps in only where the rules give up, under the same checks</a:t>
+            </a:r>
+          </a:p>
+        </p:txBody>
+      </p:sp>
+      <p:sp>
+        <p:nvSpPr>
+          <p:cNvPr id="12" name="Rounded Rectangle 11"/>
+          <p:cNvSpPr/>
+          <p:nvPr/>
+        </p:nvSpPr>
+        <p:spPr>
+          <a:xfrm>
+            <a:off x="8138160" y="1371600"/>
+            <a:ext cx="3474720" cy="3566160"/>
+          </a:xfrm>
+          <a:prstGeom prst="roundRect">
+            <a:avLst>
+              <a:gd name="adj" fmla="val 8000"/>
+            </a:avLst>
+          </a:prstGeom>
+          <a:solidFill>
+            <a:srgbClr val="F6F7F9"/>
+          </a:solidFill>
+          <a:ln w="19050">
+            <a:solidFill>
+              <a:srgbClr val="C62828"/>
+            </a:solidFill>
+          </a:ln>
+          <a:effectLst/>
+        </p:spPr>
+        <p:style>
+          <a:lnRef idx="1">
+            <a:schemeClr val="accent1"/>
+          </a:lnRef>
+          <a:fillRef idx="3">
+            <a:schemeClr val="accent1"/>
+          </a:fillRef>
+          <a:effectRef idx="2">
+            <a:schemeClr val="accent1"/>
+          </a:effectRef>
+          <a:fontRef idx="minor">
+            <a:schemeClr val="lt1"/>
+          </a:fontRef>
+        </p:style>
+        <p:txBody>
+          <a:bodyPr rtlCol="0" anchor="ctr"/>
+          <a:lstStyle/>
+          <a:p>
+            <a:pPr algn="ctr"/>
+          </a:p>
+        </p:txBody>
+      </p:sp>
+      <p:sp>
+        <p:nvSpPr>
+          <p:cNvPr id="13" name="TextBox 12"/>
+          <p:cNvSpPr txBox="1"/>
+          <p:nvPr/>
+        </p:nvSpPr>
+        <p:spPr>
+          <a:xfrm>
+            <a:off x="8366760" y="1554480"/>
+            <a:ext cx="3017520" cy="457200"/>
+          </a:xfrm>
+          <a:prstGeom prst="rect">
+            <a:avLst/>
+          </a:prstGeom>
+          <a:noFill/>
+        </p:spPr>
+        <p:txBody>
+          <a:bodyPr wrap="square" anchor="t" lIns="45720" rIns="45720">
+            <a:spAutoFit/>
+          </a:bodyPr>
+          <a:lstStyle/>
+          <a:p>
+            <a:pPr algn="l"/>
+            <a:r>
+              <a:rPr sz="2000" b="1">
+                <a:solidFill>
+                  <a:srgbClr val="C62828"/>
+                </a:solidFill>
+                <a:latin typeface="Inter"/>
+              </a:rPr>
+              <a:t>The access body</a:t>
+            </a:r>
+          </a:p>
+        </p:txBody>
+      </p:sp>
+      <p:sp>
+        <p:nvSpPr>
+          <p:cNvPr id="14" name="TextBox 13"/>
+          <p:cNvSpPr txBox="1"/>
+          <p:nvPr/>
+        </p:nvSpPr>
+        <p:spPr>
+          <a:xfrm>
+            <a:off x="8366760" y="2103120"/>
+            <a:ext cx="3017520" cy="2651760"/>
+          </a:xfrm>
+          <a:prstGeom prst="rect">
+            <a:avLst/>
+          </a:prstGeom>
+          <a:noFill/>
+        </p:spPr>
+        <p:txBody>
+          <a:bodyPr wrap="square">
+            <a:spAutoFit/>
+          </a:bodyPr>
+          <a:lstStyle/>
+          <a:p>
+            <a:pPr>
+              <a:spcAft>
+                <a:spcPts val="800"/>
+              </a:spcAft>
+            </a:pPr>
+            <a:r>
+              <a:rPr sz="1500" b="1">
+                <a:solidFill>
+                  <a:srgbClr val="1F2A37"/>
+                </a:solidFill>
+                <a:latin typeface="Inter"/>
+              </a:rPr>
+              <a:t>•  the law check quotes the article, verbatim from the regulation</a:t>
+            </a:r>
+          </a:p>
+          <a:p>
+            <a:pPr>
+              <a:spcAft>
+                <a:spcPts val="800"/>
+              </a:spcAft>
+            </a:pPr>
+            <a:r>
+              <a:rPr sz="1500" b="1">
+                <a:solidFill>
+                  <a:srgbClr val="1F2A37"/>
+                </a:solidFill>
+                <a:latin typeface="Inter"/>
+              </a:rPr>
+              <a:t>•  small-cell rule and opt-outs enforced inside the query</a:t>
+            </a:r>
+          </a:p>
+          <a:p>
+            <a:pPr>
+              <a:spcAft>
+                <a:spcPts val="800"/>
+              </a:spcAft>
+            </a:pPr>
+            <a:r>
+              <a:rPr sz="1500" b="1">
+                <a:solidFill>
+                  <a:srgbClr val="1F2A37"/>
+                </a:solidFill>
+                <a:latin typeface="Inter"/>
+              </a:rPr>
+              <a:t>•  records only in a secure room: images, no download, audit log</a:t>
+            </a:r>
+          </a:p>
+        </p:txBody>
+      </p:sp>
+      <p:sp>
+        <p:nvSpPr>
+          <p:cNvPr id="15" name="Rounded Rectangle 14"/>
+          <p:cNvSpPr/>
+          <p:nvPr/>
+        </p:nvSpPr>
+        <p:spPr>
+          <a:xfrm>
+            <a:off x="548640" y="5212080"/>
+            <a:ext cx="11064240" cy="914400"/>
+          </a:xfrm>
+          <a:prstGeom prst="roundRect">
+            <a:avLst>
+              <a:gd name="adj" fmla="val 8000"/>
+            </a:avLst>
+          </a:prstGeom>
+          <a:solidFill>
+            <a:srgbClr val="1F3A5F"/>
+          </a:solidFill>
+          <a:ln>
+            <a:noFill/>
+          </a:ln>
+          <a:effectLst/>
+        </p:spPr>
+        <p:style>
+          <a:lnRef idx="1">
+            <a:schemeClr val="accent1"/>
+          </a:lnRef>
+          <a:fillRef idx="3">
+            <a:schemeClr val="accent1"/>
+          </a:fillRef>
+          <a:effectRef idx="2">
+            <a:schemeClr val="accent1"/>
+          </a:effectRef>
+          <a:fontRef idx="minor">
+            <a:schemeClr val="lt1"/>
+          </a:fontRef>
+        </p:style>
+        <p:txBody>
+          <a:bodyPr rtlCol="0" anchor="ctr"/>
+          <a:lstStyle/>
+          <a:p>
+            <a:pPr algn="ctr"/>
+          </a:p>
+        </p:txBody>
+      </p:sp>
+      <p:sp>
+        <p:nvSpPr>
+          <p:cNvPr id="16" name="TextBox 15"/>
+          <p:cNvSpPr txBox="1"/>
+          <p:nvPr/>
+        </p:nvSpPr>
+        <p:spPr>
+          <a:xfrm>
+            <a:off x="822960" y="5212080"/>
+            <a:ext cx="10515600" cy="914400"/>
+          </a:xfrm>
+          <a:prstGeom prst="rect">
+            <a:avLst/>
+          </a:prstGeom>
+          <a:noFill/>
+        </p:spPr>
+        <p:txBody>
+          <a:bodyPr wrap="square" anchor="ctr" lIns="45720" rIns="45720">
+            <a:spAutoFit/>
+          </a:bodyPr>
+          <a:lstStyle/>
+          <a:p>
+            <a:pPr algn="l"/>
+            <a:r>
+              <a:rPr sz="1800" b="1">
+                <a:solidFill>
+                  <a:srgbClr val="FFFFFF"/>
+                </a:solidFill>
+                <a:latin typeface="Inter"/>
+              </a:rPr>
+              <a:t>Decisions in seconds instead of weeks — every one of them explained, and identical on every run.</a:t>
+            </a:r>
+          </a:p>
+        </p:txBody>
+      </p:sp>
+      <p:sp>
+        <p:nvSpPr>
+          <p:cNvPr id="17" name="TextBox 16"/>
           <p:cNvSpPr txBox="1"/>
           <p:nvPr/>
         </p:nvSpPr>
@@ -5100,7 +5690,7 @@
                 </a:solidFill>
                 <a:latin typeface="Inter"/>
               </a:rPr>
-              <a:t>Why this is better than a black box</a:t>
+              <a:t>What we built: one pipeline, three outcomes</a:t>
             </a:r>
           </a:p>
         </p:txBody>
@@ -5135,7 +5725,7 @@
                 </a:solidFill>
                 <a:latin typeface="Inter"/>
               </a:rPr>
-              <a:t>grounded, fast, consistent, safe</a:t>
+              <a:t>request → law check → statistics or secure room; attackers blocked</a:t>
             </a:r>
           </a:p>
         </p:txBody>
@@ -5175,182 +5765,9 @@
           </a:p>
         </p:txBody>
       </p:sp>
-      <p:sp>
-        <p:nvSpPr>
-          <p:cNvPr id="6" name="TextBox 5"/>
-          <p:cNvSpPr txBox="1"/>
-          <p:nvPr/>
-        </p:nvSpPr>
-        <p:spPr>
-          <a:xfrm>
-            <a:off x="548640" y="1371600"/>
-            <a:ext cx="5760720" cy="4572000"/>
-          </a:xfrm>
-          <a:prstGeom prst="rect">
-            <a:avLst/>
-          </a:prstGeom>
-          <a:noFill/>
-        </p:spPr>
-        <p:txBody>
-          <a:bodyPr wrap="square">
-            <a:spAutoFit/>
-          </a:bodyPr>
-          <a:lstStyle/>
-          <a:p>
-            <a:pPr>
-              <a:spcAft>
-                <a:spcPts val="1000"/>
-              </a:spcAft>
-            </a:pPr>
-            <a:r>
-              <a:rPr sz="1700" b="1">
-                <a:solidFill>
-                  <a:srgbClr val="1F2A37"/>
-                </a:solidFill>
-                <a:latin typeface="Inter"/>
-              </a:rPr>
-              <a:t>•  No technical burden.</a:t>
-            </a:r>
-            <a:r>
-              <a:rPr sz="1700">
-                <a:solidFill>
-                  <a:srgbClr val="5B6472"/>
-                </a:solidFill>
-                <a:latin typeface="Inter"/>
-              </a:rPr>
-              <a:t> Plain words in; the AI drafts the definitions the access body can compute.</a:t>
-            </a:r>
-          </a:p>
-          <a:p>
-            <a:pPr>
-              <a:spcAft>
-                <a:spcPts val="1000"/>
-              </a:spcAft>
-            </a:pPr>
-            <a:r>
-              <a:rPr sz="1700" b="1">
-                <a:solidFill>
-                  <a:srgbClr val="1F2A37"/>
-                </a:solidFill>
-                <a:latin typeface="Inter"/>
-              </a:rPr>
-              <a:t>•  Explainable, not a verdict.</a:t>
-            </a:r>
-            <a:r>
-              <a:rPr sz="1700">
-                <a:solidFill>
-                  <a:srgbClr val="5B6472"/>
-                </a:solidFill>
-                <a:latin typeface="Inter"/>
-              </a:rPr>
-              <a:t> Every decision quotes the article, verbatim from the law text.</a:t>
-            </a:r>
-          </a:p>
-          <a:p>
-            <a:pPr>
-              <a:spcAft>
-                <a:spcPts val="1000"/>
-              </a:spcAft>
-            </a:pPr>
-            <a:r>
-              <a:rPr sz="1700" b="1">
-                <a:solidFill>
-                  <a:srgbClr val="1F2A37"/>
-                </a:solidFill>
-                <a:latin typeface="Inter"/>
-              </a:rPr>
-              <a:t>•  Numbers from code, not from the AI.</a:t>
-            </a:r>
-            <a:r>
-              <a:rPr sz="1700">
-                <a:solidFill>
-                  <a:srgbClr val="5B6472"/>
-                </a:solidFill>
-                <a:latin typeface="Inter"/>
-              </a:rPr>
-              <a:t> Same answer on every run; 10/10 consistent across 3 runs.</a:t>
-            </a:r>
-          </a:p>
-          <a:p>
-            <a:pPr>
-              <a:spcAft>
-                <a:spcPts val="1000"/>
-              </a:spcAft>
-            </a:pPr>
-            <a:r>
-              <a:rPr sz="1700" b="1">
-                <a:solidFill>
-                  <a:srgbClr val="1F2A37"/>
-                </a:solidFill>
-                <a:latin typeface="Inter"/>
-              </a:rPr>
-              <a:t>•  Privacy enforced in the query.</a:t>
-            </a:r>
-            <a:r>
-              <a:rPr sz="1700">
-                <a:solidFill>
-                  <a:srgbClr val="5B6472"/>
-                </a:solidFill>
-                <a:latin typeface="Inter"/>
-              </a:rPr>
-              <a:t> &lt;10, suppressed, opt-outs out — no answer can bypass it.</a:t>
-            </a:r>
-          </a:p>
-          <a:p>
-            <a:pPr>
-              <a:spcAft>
-                <a:spcPts val="1000"/>
-              </a:spcAft>
-            </a:pPr>
-            <a:r>
-              <a:rPr sz="1700" b="1">
-                <a:solidFill>
-                  <a:srgbClr val="1F2A37"/>
-                </a:solidFill>
-                <a:latin typeface="Inter"/>
-              </a:rPr>
-              <a:t>•  Any EU language, one rulebook.</a:t>
-            </a:r>
-            <a:r>
-              <a:rPr sz="1700">
-                <a:solidFill>
-                  <a:srgbClr val="5B6472"/>
-                </a:solidFill>
-                <a:latin typeface="Inter"/>
-              </a:rPr>
-              <a:t> German, Swedish, Greek → English once, then the same checks.</a:t>
-            </a:r>
-          </a:p>
-          <a:p>
-            <a:pPr>
-              <a:spcAft>
-                <a:spcPts val="1000"/>
-              </a:spcAft>
-            </a:pPr>
-            <a:r>
-              <a:rPr sz="1700" b="1">
-                <a:solidFill>
-                  <a:srgbClr val="1F2A37"/>
-                </a:solidFill>
-                <a:latin typeface="Inter"/>
-              </a:rPr>
-              <a:t>•  Audit and abuse control.</a:t>
-            </a:r>
-            <a:r>
-              <a:rPr sz="1700">
-                <a:solidFill>
-                  <a:srgbClr val="5B6472"/>
-                </a:solidFill>
-                <a:latin typeface="Inter"/>
-              </a:rPr>
-              <a:t> Every SPE action logged; flooding addresses blocked (429).</a:t>
-            </a:r>
-          </a:p>
-        </p:txBody>
-      </p:sp>
       <p:pic>
         <p:nvPicPr>
-          <p:cNvPr id="7" name="Picture 6" descr="ui-reject.png"/>
+          <p:cNvPr id="6" name="Picture 5" descr="how-it-works.png"/>
           <p:cNvPicPr>
             <a:picLocks noChangeAspect="1"/>
           </p:cNvPicPr>
@@ -5364,8 +5781,8 @@
         </p:blipFill>
         <p:spPr>
           <a:xfrm>
-            <a:off x="6583680" y="1505402"/>
-            <a:ext cx="5212080" cy="4487275"/>
+            <a:off x="365760" y="1218111"/>
+            <a:ext cx="11430000" cy="5061857"/>
           </a:xfrm>
           <a:prstGeom prst="rect">
             <a:avLst/>
@@ -5374,7 +5791,7 @@
       </p:pic>
       <p:sp>
         <p:nvSpPr>
-          <p:cNvPr id="8" name="TextBox 7"/>
+          <p:cNvPr id="7" name="TextBox 6"/>
           <p:cNvSpPr txBox="1"/>
           <p:nvPr/>
         </p:nvSpPr>
@@ -5434,7 +5851,7 @@
         <p:spPr>
           <a:xfrm>
             <a:off x="0" y="0"/>
-            <a:ext cx="12191695" cy="6858000"/>
+            <a:ext cx="12191695" cy="1051560"/>
           </a:xfrm>
           <a:prstGeom prst="rect">
             <a:avLst/>
@@ -5477,8 +5894,8 @@
         </p:nvSpPr>
         <p:spPr>
           <a:xfrm>
-            <a:off x="822960" y="1097280"/>
-            <a:ext cx="10515600" cy="914400"/>
+            <a:off x="548640" y="182880"/>
+            <a:ext cx="8412480" cy="548640"/>
           </a:xfrm>
           <a:prstGeom prst="rect">
             <a:avLst/>
@@ -5493,35 +5910,353 @@
           <a:p>
             <a:pPr algn="l"/>
             <a:r>
-              <a:rPr sz="4400" b="1">
+              <a:rPr sz="2600" b="1">
                 <a:solidFill>
                   <a:srgbClr val="FFFFFF"/>
                 </a:solidFill>
                 <a:latin typeface="Inter"/>
               </a:rPr>
-              <a:t>Demo</a:t>
-            </a:r>
-          </a:p>
-        </p:txBody>
-      </p:sp>
-      <p:sp>
-        <p:nvSpPr>
-          <p:cNvPr id="4" name="Rounded Rectangle 3"/>
+              <a:t>Why this is better than a black box</a:t>
+            </a:r>
+          </a:p>
+        </p:txBody>
+      </p:sp>
+      <p:sp>
+        <p:nvSpPr>
+          <p:cNvPr id="4" name="TextBox 3"/>
+          <p:cNvSpPr txBox="1"/>
+          <p:nvPr/>
+        </p:nvSpPr>
+        <p:spPr>
+          <a:xfrm>
+            <a:off x="548640" y="658368"/>
+            <a:ext cx="8412480" cy="365760"/>
+          </a:xfrm>
+          <a:prstGeom prst="rect">
+            <a:avLst/>
+          </a:prstGeom>
+          <a:noFill/>
+        </p:spPr>
+        <p:txBody>
+          <a:bodyPr wrap="square" anchor="t" lIns="45720" rIns="45720">
+            <a:spAutoFit/>
+          </a:bodyPr>
+          <a:lstStyle/>
+          <a:p>
+            <a:pPr algn="l"/>
+            <a:r>
+              <a:rPr sz="1300" b="0">
+                <a:solidFill>
+                  <a:srgbClr val="DBE6F3"/>
+                </a:solidFill>
+                <a:latin typeface="Inter"/>
+              </a:rPr>
+              <a:t>grounded, fast, consistent, safe</a:t>
+            </a:r>
+          </a:p>
+        </p:txBody>
+      </p:sp>
+      <p:sp>
+        <p:nvSpPr>
+          <p:cNvPr id="5" name="TextBox 4"/>
+          <p:cNvSpPr txBox="1"/>
+          <p:nvPr/>
+        </p:nvSpPr>
+        <p:spPr>
+          <a:xfrm>
+            <a:off x="8503920" y="320040"/>
+            <a:ext cx="3200400" cy="457200"/>
+          </a:xfrm>
+          <a:prstGeom prst="rect">
+            <a:avLst/>
+          </a:prstGeom>
+          <a:noFill/>
+        </p:spPr>
+        <p:txBody>
+          <a:bodyPr wrap="square" anchor="t" lIns="45720" rIns="45720">
+            <a:spAutoFit/>
+          </a:bodyPr>
+          <a:lstStyle/>
+          <a:p>
+            <a:pPr algn="r"/>
+            <a:r>
+              <a:rPr sz="1200" b="0">
+                <a:solidFill>
+                  <a:srgbClr val="DBE6F3"/>
+                </a:solidFill>
+                <a:latin typeface="Inter"/>
+              </a:rPr>
+              <a:t>HalfSecuredTeam · Track 3</a:t>
+            </a:r>
+          </a:p>
+        </p:txBody>
+      </p:sp>
+      <p:sp>
+        <p:nvSpPr>
+          <p:cNvPr id="6" name="TextBox 5"/>
+          <p:cNvSpPr txBox="1"/>
+          <p:nvPr/>
+        </p:nvSpPr>
+        <p:spPr>
+          <a:xfrm>
+            <a:off x="548640" y="1371600"/>
+            <a:ext cx="5760720" cy="4572000"/>
+          </a:xfrm>
+          <a:prstGeom prst="rect">
+            <a:avLst/>
+          </a:prstGeom>
+          <a:noFill/>
+        </p:spPr>
+        <p:txBody>
+          <a:bodyPr wrap="square">
+            <a:spAutoFit/>
+          </a:bodyPr>
+          <a:lstStyle/>
+          <a:p>
+            <a:pPr>
+              <a:spcAft>
+                <a:spcPts val="1000"/>
+              </a:spcAft>
+            </a:pPr>
+            <a:r>
+              <a:rPr sz="1700" b="1">
+                <a:solidFill>
+                  <a:srgbClr val="1F2A37"/>
+                </a:solidFill>
+                <a:latin typeface="Inter"/>
+              </a:rPr>
+              <a:t>•  No technical burden.</a:t>
+            </a:r>
+            <a:r>
+              <a:rPr sz="1700">
+                <a:solidFill>
+                  <a:srgbClr val="5B6472"/>
+                </a:solidFill>
+                <a:latin typeface="Inter"/>
+              </a:rPr>
+              <a:t> Plain words in; the AI drafts the definitions the access body can compute.</a:t>
+            </a:r>
+          </a:p>
+          <a:p>
+            <a:pPr>
+              <a:spcAft>
+                <a:spcPts val="1000"/>
+              </a:spcAft>
+            </a:pPr>
+            <a:r>
+              <a:rPr sz="1700" b="1">
+                <a:solidFill>
+                  <a:srgbClr val="1F2A37"/>
+                </a:solidFill>
+                <a:latin typeface="Inter"/>
+              </a:rPr>
+              <a:t>•  Explainable, not a verdict.</a:t>
+            </a:r>
+            <a:r>
+              <a:rPr sz="1700">
+                <a:solidFill>
+                  <a:srgbClr val="5B6472"/>
+                </a:solidFill>
+                <a:latin typeface="Inter"/>
+              </a:rPr>
+              <a:t> Every decision quotes the article, verbatim from the law text.</a:t>
+            </a:r>
+          </a:p>
+          <a:p>
+            <a:pPr>
+              <a:spcAft>
+                <a:spcPts val="1000"/>
+              </a:spcAft>
+            </a:pPr>
+            <a:r>
+              <a:rPr sz="1700" b="1">
+                <a:solidFill>
+                  <a:srgbClr val="1F2A37"/>
+                </a:solidFill>
+                <a:latin typeface="Inter"/>
+              </a:rPr>
+              <a:t>•  Numbers from code, not from the AI.</a:t>
+            </a:r>
+            <a:r>
+              <a:rPr sz="1700">
+                <a:solidFill>
+                  <a:srgbClr val="5B6472"/>
+                </a:solidFill>
+                <a:latin typeface="Inter"/>
+              </a:rPr>
+              <a:t> Same answer on every run; 10/10 consistent across 3 runs.</a:t>
+            </a:r>
+          </a:p>
+          <a:p>
+            <a:pPr>
+              <a:spcAft>
+                <a:spcPts val="1000"/>
+              </a:spcAft>
+            </a:pPr>
+            <a:r>
+              <a:rPr sz="1700" b="1">
+                <a:solidFill>
+                  <a:srgbClr val="1F2A37"/>
+                </a:solidFill>
+                <a:latin typeface="Inter"/>
+              </a:rPr>
+              <a:t>•  Privacy enforced in the query.</a:t>
+            </a:r>
+            <a:r>
+              <a:rPr sz="1700">
+                <a:solidFill>
+                  <a:srgbClr val="5B6472"/>
+                </a:solidFill>
+                <a:latin typeface="Inter"/>
+              </a:rPr>
+              <a:t> &lt;10, suppressed, opt-outs out — no answer can bypass it.</a:t>
+            </a:r>
+          </a:p>
+          <a:p>
+            <a:pPr>
+              <a:spcAft>
+                <a:spcPts val="1000"/>
+              </a:spcAft>
+            </a:pPr>
+            <a:r>
+              <a:rPr sz="1700" b="1">
+                <a:solidFill>
+                  <a:srgbClr val="1F2A37"/>
+                </a:solidFill>
+                <a:latin typeface="Inter"/>
+              </a:rPr>
+              <a:t>•  Any EU language, one rulebook.</a:t>
+            </a:r>
+            <a:r>
+              <a:rPr sz="1700">
+                <a:solidFill>
+                  <a:srgbClr val="5B6472"/>
+                </a:solidFill>
+                <a:latin typeface="Inter"/>
+              </a:rPr>
+              <a:t> German, Swedish, Greek → English once, then the same checks.</a:t>
+            </a:r>
+          </a:p>
+          <a:p>
+            <a:pPr>
+              <a:spcAft>
+                <a:spcPts val="1000"/>
+              </a:spcAft>
+            </a:pPr>
+            <a:r>
+              <a:rPr sz="1700" b="1">
+                <a:solidFill>
+                  <a:srgbClr val="1F2A37"/>
+                </a:solidFill>
+                <a:latin typeface="Inter"/>
+              </a:rPr>
+              <a:t>•  Audit and abuse control.</a:t>
+            </a:r>
+            <a:r>
+              <a:rPr sz="1700">
+                <a:solidFill>
+                  <a:srgbClr val="5B6472"/>
+                </a:solidFill>
+                <a:latin typeface="Inter"/>
+              </a:rPr>
+              <a:t> Every SPE action logged; flooding addresses blocked (429).</a:t>
+            </a:r>
+          </a:p>
+        </p:txBody>
+      </p:sp>
+      <p:pic>
+        <p:nvPicPr>
+          <p:cNvPr id="7" name="Picture 6" descr="ui-reject.png"/>
+          <p:cNvPicPr>
+            <a:picLocks noChangeAspect="1"/>
+          </p:cNvPicPr>
+          <p:nvPr/>
+        </p:nvPicPr>
+        <p:blipFill>
+          <a:blip r:embed="rId2"/>
+          <a:stretch>
+            <a:fillRect/>
+          </a:stretch>
+        </p:blipFill>
+        <p:spPr>
+          <a:xfrm>
+            <a:off x="6583680" y="1505402"/>
+            <a:ext cx="5212080" cy="4487275"/>
+          </a:xfrm>
+          <a:prstGeom prst="rect">
+            <a:avLst/>
+          </a:prstGeom>
+        </p:spPr>
+      </p:pic>
+      <p:sp>
+        <p:nvSpPr>
+          <p:cNvPr id="8" name="TextBox 7"/>
+          <p:cNvSpPr txBox="1"/>
+          <p:nvPr/>
+        </p:nvSpPr>
+        <p:spPr>
+          <a:xfrm>
+            <a:off x="548640" y="6446520"/>
+            <a:ext cx="10972800" cy="274320"/>
+          </a:xfrm>
+          <a:prstGeom prst="rect">
+            <a:avLst/>
+          </a:prstGeom>
+          <a:noFill/>
+        </p:spPr>
+        <p:txBody>
+          <a:bodyPr wrap="square" anchor="t" lIns="45720" rIns="45720">
+            <a:spAutoFit/>
+          </a:bodyPr>
+          <a:lstStyle/>
+          <a:p>
+            <a:pPr algn="l"/>
+            <a:r>
+              <a:rPr sz="1000" b="0">
+                <a:solidFill>
+                  <a:srgbClr val="5B6472"/>
+                </a:solidFill>
+                <a:latin typeface="Inter"/>
+              </a:rPr>
+              <a:t>EHDS · Regulation (EU) 2025/327 · synthetic data only</a:t>
+            </a:r>
+          </a:p>
+        </p:txBody>
+      </p:sp>
+    </p:spTree>
+  </p:cSld>
+  <p:clrMapOvr>
+    <a:masterClrMapping/>
+  </p:clrMapOvr>
+</p:sld>
+</file>
+
+<file path=ppt/slides/slide6.xml><?xml version="1.0" encoding="utf-8"?>
+<p:sld xmlns:a="http://schemas.openxmlformats.org/drawingml/2006/main" xmlns:p="http://schemas.openxmlformats.org/presentationml/2006/main" xmlns:r="http://schemas.openxmlformats.org/officeDocument/2006/relationships">
+  <p:cSld>
+    <p:spTree>
+      <p:nvGrpSpPr>
+        <p:cNvPr id="1" name=""/>
+        <p:cNvGrpSpPr/>
+        <p:nvPr/>
+      </p:nvGrpSpPr>
+      <p:grpSpPr/>
+      <p:sp>
+        <p:nvSpPr>
+          <p:cNvPr id="2" name="Rectangle 1"/>
           <p:cNvSpPr/>
           <p:nvPr/>
         </p:nvSpPr>
         <p:spPr>
           <a:xfrm>
-            <a:off x="822960" y="2377440"/>
-            <a:ext cx="2103120" cy="2926080"/>
-          </a:xfrm>
-          <a:prstGeom prst="roundRect">
-            <a:avLst>
-              <a:gd name="adj" fmla="val 8000"/>
-            </a:avLst>
+            <a:off x="0" y="0"/>
+            <a:ext cx="12191695" cy="6858000"/>
+          </a:xfrm>
+          <a:prstGeom prst="rect">
+            <a:avLst/>
           </a:prstGeom>
           <a:solidFill>
-            <a:srgbClr val="FFFFFF"/>
+            <a:srgbClr val="1F3A5F"/>
           </a:solidFill>
           <a:ln>
             <a:noFill/>
@@ -5552,14 +6287,49 @@
       </p:sp>
       <p:sp>
         <p:nvSpPr>
-          <p:cNvPr id="5" name="Rounded Rectangle 4"/>
+          <p:cNvPr id="3" name="TextBox 2"/>
+          <p:cNvSpPr txBox="1"/>
+          <p:nvPr/>
+        </p:nvSpPr>
+        <p:spPr>
+          <a:xfrm>
+            <a:off x="822960" y="1097280"/>
+            <a:ext cx="10515600" cy="914400"/>
+          </a:xfrm>
+          <a:prstGeom prst="rect">
+            <a:avLst/>
+          </a:prstGeom>
+          <a:noFill/>
+        </p:spPr>
+        <p:txBody>
+          <a:bodyPr wrap="square" anchor="t" lIns="45720" rIns="45720">
+            <a:spAutoFit/>
+          </a:bodyPr>
+          <a:lstStyle/>
+          <a:p>
+            <a:pPr algn="l"/>
+            <a:r>
+              <a:rPr sz="4400" b="1">
+                <a:solidFill>
+                  <a:srgbClr val="FFFFFF"/>
+                </a:solidFill>
+                <a:latin typeface="Inter"/>
+              </a:rPr>
+              <a:t>Demo</a:t>
+            </a:r>
+          </a:p>
+        </p:txBody>
+      </p:sp>
+      <p:sp>
+        <p:nvSpPr>
+          <p:cNvPr id="4" name="Rounded Rectangle 3"/>
           <p:cNvSpPr/>
           <p:nvPr/>
         </p:nvSpPr>
         <p:spPr>
           <a:xfrm>
             <a:off x="822960" y="2377440"/>
-            <a:ext cx="2103120" cy="640080"/>
+            <a:ext cx="2103120" cy="2926080"/>
           </a:xfrm>
           <a:prstGeom prst="roundRect">
             <a:avLst>
@@ -5567,7 +6337,7 @@
             </a:avLst>
           </a:prstGeom>
           <a:solidFill>
-            <a:srgbClr val="C62828"/>
+            <a:srgbClr val="FFFFFF"/>
           </a:solidFill>
           <a:ln>
             <a:noFill/>
@@ -5598,119 +6368,14 @@
       </p:sp>
       <p:sp>
         <p:nvSpPr>
-          <p:cNvPr id="6" name="TextBox 5"/>
-          <p:cNvSpPr txBox="1"/>
+          <p:cNvPr id="5" name="Rounded Rectangle 4"/>
+          <p:cNvSpPr/>
           <p:nvPr/>
         </p:nvSpPr>
         <p:spPr>
           <a:xfrm>
             <a:off x="822960" y="2377440"/>
             <a:ext cx="2103120" cy="640080"/>
-          </a:xfrm>
-          <a:prstGeom prst="rect">
-            <a:avLst/>
-          </a:prstGeom>
-          <a:noFill/>
-        </p:spPr>
-        <p:txBody>
-          <a:bodyPr wrap="square" anchor="ctr" lIns="45720" rIns="45720">
-            <a:spAutoFit/>
-          </a:bodyPr>
-          <a:lstStyle/>
-          <a:p>
-            <a:pPr algn="ctr"/>
-            <a:r>
-              <a:rPr sz="2000" b="1">
-                <a:solidFill>
-                  <a:srgbClr val="FFFFFF"/>
-                </a:solidFill>
-                <a:latin typeface="Inter"/>
-              </a:rPr>
-              <a:t>R02</a:t>
-            </a:r>
-          </a:p>
-        </p:txBody>
-      </p:sp>
-      <p:sp>
-        <p:nvSpPr>
-          <p:cNvPr id="7" name="TextBox 6"/>
-          <p:cNvSpPr txBox="1"/>
-          <p:nvPr/>
-        </p:nvSpPr>
-        <p:spPr>
-          <a:xfrm>
-            <a:off x="960120" y="3154680"/>
-            <a:ext cx="1828800" cy="1097280"/>
-          </a:xfrm>
-          <a:prstGeom prst="rect">
-            <a:avLst/>
-          </a:prstGeom>
-          <a:noFill/>
-        </p:spPr>
-        <p:txBody>
-          <a:bodyPr wrap="square" anchor="t" lIns="45720" rIns="45720">
-            <a:spAutoFit/>
-          </a:bodyPr>
-          <a:lstStyle/>
-          <a:p>
-            <a:pPr algn="ctr"/>
-            <a:r>
-              <a:rPr sz="1500" b="0">
-                <a:solidFill>
-                  <a:srgbClr val="1F2A37"/>
-                </a:solidFill>
-                <a:latin typeface="Inter"/>
-              </a:rPr>
-              <a:t>Insurer wants to price premiums</a:t>
-            </a:r>
-          </a:p>
-        </p:txBody>
-      </p:sp>
-      <p:sp>
-        <p:nvSpPr>
-          <p:cNvPr id="8" name="TextBox 7"/>
-          <p:cNvSpPr txBox="1"/>
-          <p:nvPr/>
-        </p:nvSpPr>
-        <p:spPr>
-          <a:xfrm>
-            <a:off x="960120" y="4206240"/>
-            <a:ext cx="1828800" cy="1005840"/>
-          </a:xfrm>
-          <a:prstGeom prst="rect">
-            <a:avLst/>
-          </a:prstGeom>
-          <a:noFill/>
-        </p:spPr>
-        <p:txBody>
-          <a:bodyPr wrap="square" anchor="t" lIns="45720" rIns="45720">
-            <a:spAutoFit/>
-          </a:bodyPr>
-          <a:lstStyle/>
-          <a:p>
-            <a:pPr algn="ctr"/>
-            <a:r>
-              <a:rPr sz="1500" b="1">
-                <a:solidFill>
-                  <a:srgbClr val="C62828"/>
-                </a:solidFill>
-                <a:latin typeface="Inter"/>
-              </a:rPr>
-              <a:t>Rejected — Art. 54(b) quoted</a:t>
-            </a:r>
-          </a:p>
-        </p:txBody>
-      </p:sp>
-      <p:sp>
-        <p:nvSpPr>
-          <p:cNvPr id="9" name="Rounded Rectangle 8"/>
-          <p:cNvSpPr/>
-          <p:nvPr/>
-        </p:nvSpPr>
-        <p:spPr>
-          <a:xfrm>
-            <a:off x="3063240" y="2377440"/>
-            <a:ext cx="2103120" cy="2926080"/>
           </a:xfrm>
           <a:prstGeom prst="roundRect">
             <a:avLst>
@@ -5718,7 +6383,7 @@
             </a:avLst>
           </a:prstGeom>
           <a:solidFill>
-            <a:srgbClr val="FFFFFF"/>
+            <a:srgbClr val="C62828"/>
           </a:solidFill>
           <a:ln>
             <a:noFill/>
@@ -5749,14 +6414,119 @@
       </p:sp>
       <p:sp>
         <p:nvSpPr>
-          <p:cNvPr id="10" name="Rounded Rectangle 9"/>
+          <p:cNvPr id="6" name="TextBox 5"/>
+          <p:cNvSpPr txBox="1"/>
+          <p:nvPr/>
+        </p:nvSpPr>
+        <p:spPr>
+          <a:xfrm>
+            <a:off x="822960" y="2377440"/>
+            <a:ext cx="2103120" cy="640080"/>
+          </a:xfrm>
+          <a:prstGeom prst="rect">
+            <a:avLst/>
+          </a:prstGeom>
+          <a:noFill/>
+        </p:spPr>
+        <p:txBody>
+          <a:bodyPr wrap="square" anchor="ctr" lIns="45720" rIns="45720">
+            <a:spAutoFit/>
+          </a:bodyPr>
+          <a:lstStyle/>
+          <a:p>
+            <a:pPr algn="ctr"/>
+            <a:r>
+              <a:rPr sz="2000" b="1">
+                <a:solidFill>
+                  <a:srgbClr val="FFFFFF"/>
+                </a:solidFill>
+                <a:latin typeface="Inter"/>
+              </a:rPr>
+              <a:t>R02</a:t>
+            </a:r>
+          </a:p>
+        </p:txBody>
+      </p:sp>
+      <p:sp>
+        <p:nvSpPr>
+          <p:cNvPr id="7" name="TextBox 6"/>
+          <p:cNvSpPr txBox="1"/>
+          <p:nvPr/>
+        </p:nvSpPr>
+        <p:spPr>
+          <a:xfrm>
+            <a:off x="960120" y="3154680"/>
+            <a:ext cx="1828800" cy="1097280"/>
+          </a:xfrm>
+          <a:prstGeom prst="rect">
+            <a:avLst/>
+          </a:prstGeom>
+          <a:noFill/>
+        </p:spPr>
+        <p:txBody>
+          <a:bodyPr wrap="square" anchor="t" lIns="45720" rIns="45720">
+            <a:spAutoFit/>
+          </a:bodyPr>
+          <a:lstStyle/>
+          <a:p>
+            <a:pPr algn="ctr"/>
+            <a:r>
+              <a:rPr sz="1500" b="0">
+                <a:solidFill>
+                  <a:srgbClr val="1F2A37"/>
+                </a:solidFill>
+                <a:latin typeface="Inter"/>
+              </a:rPr>
+              <a:t>Insurer wants to price premiums</a:t>
+            </a:r>
+          </a:p>
+        </p:txBody>
+      </p:sp>
+      <p:sp>
+        <p:nvSpPr>
+          <p:cNvPr id="8" name="TextBox 7"/>
+          <p:cNvSpPr txBox="1"/>
+          <p:nvPr/>
+        </p:nvSpPr>
+        <p:spPr>
+          <a:xfrm>
+            <a:off x="960120" y="4206240"/>
+            <a:ext cx="1828800" cy="1005840"/>
+          </a:xfrm>
+          <a:prstGeom prst="rect">
+            <a:avLst/>
+          </a:prstGeom>
+          <a:noFill/>
+        </p:spPr>
+        <p:txBody>
+          <a:bodyPr wrap="square" anchor="t" lIns="45720" rIns="45720">
+            <a:spAutoFit/>
+          </a:bodyPr>
+          <a:lstStyle/>
+          <a:p>
+            <a:pPr algn="ctr"/>
+            <a:r>
+              <a:rPr sz="1500" b="1">
+                <a:solidFill>
+                  <a:srgbClr val="C62828"/>
+                </a:solidFill>
+                <a:latin typeface="Inter"/>
+              </a:rPr>
+              <a:t>Rejected — Art. 54(b) quoted</a:t>
+            </a:r>
+          </a:p>
+        </p:txBody>
+      </p:sp>
+      <p:sp>
+        <p:nvSpPr>
+          <p:cNvPr id="9" name="Rounded Rectangle 8"/>
           <p:cNvSpPr/>
           <p:nvPr/>
         </p:nvSpPr>
         <p:spPr>
           <a:xfrm>
             <a:off x="3063240" y="2377440"/>
-            <a:ext cx="2103120" cy="640080"/>
+            <a:ext cx="2103120" cy="2926080"/>
           </a:xfrm>
           <a:prstGeom prst="roundRect">
             <a:avLst>
@@ -5764,7 +6534,7 @@
             </a:avLst>
           </a:prstGeom>
           <a:solidFill>
-            <a:srgbClr val="2E7D32"/>
+            <a:srgbClr val="FFFFFF"/>
           </a:solidFill>
           <a:ln>
             <a:noFill/>
@@ -5795,119 +6565,14 @@
       </p:sp>
       <p:sp>
         <p:nvSpPr>
-          <p:cNvPr id="11" name="TextBox 10"/>
-          <p:cNvSpPr txBox="1"/>
+          <p:cNvPr id="10" name="Rounded Rectangle 9"/>
+          <p:cNvSpPr/>
           <p:nvPr/>
         </p:nvSpPr>
         <p:spPr>
           <a:xfrm>
             <a:off x="3063240" y="2377440"/>
             <a:ext cx="2103120" cy="640080"/>
-          </a:xfrm>
-          <a:prstGeom prst="rect">
-            <a:avLst/>
-          </a:prstGeom>
-          <a:noFill/>
-        </p:spPr>
-        <p:txBody>
-          <a:bodyPr wrap="square" anchor="ctr" lIns="45720" rIns="45720">
-            <a:spAutoFit/>
-          </a:bodyPr>
-          <a:lstStyle/>
-          <a:p>
-            <a:pPr algn="ctr"/>
-            <a:r>
-              <a:rPr sz="2000" b="1">
-                <a:solidFill>
-                  <a:srgbClr val="FFFFFF"/>
-                </a:solidFill>
-                <a:latin typeface="Inter"/>
-              </a:rPr>
-              <a:t>R01</a:t>
-            </a:r>
-          </a:p>
-        </p:txBody>
-      </p:sp>
-      <p:sp>
-        <p:nvSpPr>
-          <p:cNvPr id="12" name="TextBox 11"/>
-          <p:cNvSpPr txBox="1"/>
-          <p:nvPr/>
-        </p:nvSpPr>
-        <p:spPr>
-          <a:xfrm>
-            <a:off x="3200400" y="3154680"/>
-            <a:ext cx="1828800" cy="1097280"/>
-          </a:xfrm>
-          <a:prstGeom prst="rect">
-            <a:avLst/>
-          </a:prstGeom>
-          <a:noFill/>
-        </p:spPr>
-        <p:txBody>
-          <a:bodyPr wrap="square" anchor="t" lIns="45720" rIns="45720">
-            <a:spAutoFit/>
-          </a:bodyPr>
-          <a:lstStyle/>
-          <a:p>
-            <a:pPr algn="ctr"/>
-            <a:r>
-              <a:rPr sz="1500" b="0">
-                <a:solidFill>
-                  <a:srgbClr val="1F2A37"/>
-                </a:solidFill>
-                <a:latin typeface="Inter"/>
-              </a:rPr>
-              <a:t>Diabetes prevalence by region</a:t>
-            </a:r>
-          </a:p>
-        </p:txBody>
-      </p:sp>
-      <p:sp>
-        <p:nvSpPr>
-          <p:cNvPr id="13" name="TextBox 12"/>
-          <p:cNvSpPr txBox="1"/>
-          <p:nvPr/>
-        </p:nvSpPr>
-        <p:spPr>
-          <a:xfrm>
-            <a:off x="3200400" y="4206240"/>
-            <a:ext cx="1828800" cy="1005840"/>
-          </a:xfrm>
-          <a:prstGeom prst="rect">
-            <a:avLst/>
-          </a:prstGeom>
-          <a:noFill/>
-        </p:spPr>
-        <p:txBody>
-          <a:bodyPr wrap="square" anchor="t" lIns="45720" rIns="45720">
-            <a:spAutoFit/>
-          </a:bodyPr>
-          <a:lstStyle/>
-          <a:p>
-            <a:pPr algn="ctr"/>
-            <a:r>
-              <a:rPr sz="1500" b="1">
-                <a:solidFill>
-                  <a:srgbClr val="2E7D32"/>
-                </a:solidFill>
-                <a:latin typeface="Inter"/>
-              </a:rPr>
-              <a:t>Statistics, small cells hidden</a:t>
-            </a:r>
-          </a:p>
-        </p:txBody>
-      </p:sp>
-      <p:sp>
-        <p:nvSpPr>
-          <p:cNvPr id="14" name="Rounded Rectangle 13"/>
-          <p:cNvSpPr/>
-          <p:nvPr/>
-        </p:nvSpPr>
-        <p:spPr>
-          <a:xfrm>
-            <a:off x="5303520" y="2377440"/>
-            <a:ext cx="2103120" cy="2926080"/>
           </a:xfrm>
           <a:prstGeom prst="roundRect">
             <a:avLst>
@@ -5915,7 +6580,7 @@
             </a:avLst>
           </a:prstGeom>
           <a:solidFill>
-            <a:srgbClr val="FFFFFF"/>
+            <a:srgbClr val="2E7D32"/>
           </a:solidFill>
           <a:ln>
             <a:noFill/>
@@ -5946,14 +6611,119 @@
       </p:sp>
       <p:sp>
         <p:nvSpPr>
-          <p:cNvPr id="15" name="Rounded Rectangle 14"/>
+          <p:cNvPr id="11" name="TextBox 10"/>
+          <p:cNvSpPr txBox="1"/>
+          <p:nvPr/>
+        </p:nvSpPr>
+        <p:spPr>
+          <a:xfrm>
+            <a:off x="3063240" y="2377440"/>
+            <a:ext cx="2103120" cy="640080"/>
+          </a:xfrm>
+          <a:prstGeom prst="rect">
+            <a:avLst/>
+          </a:prstGeom>
+          <a:noFill/>
+        </p:spPr>
+        <p:txBody>
+          <a:bodyPr wrap="square" anchor="ctr" lIns="45720" rIns="45720">
+            <a:spAutoFit/>
+          </a:bodyPr>
+          <a:lstStyle/>
+          <a:p>
+            <a:pPr algn="ctr"/>
+            <a:r>
+              <a:rPr sz="2000" b="1">
+                <a:solidFill>
+                  <a:srgbClr val="FFFFFF"/>
+                </a:solidFill>
+                <a:latin typeface="Inter"/>
+              </a:rPr>
+              <a:t>R01</a:t>
+            </a:r>
+          </a:p>
+        </p:txBody>
+      </p:sp>
+      <p:sp>
+        <p:nvSpPr>
+          <p:cNvPr id="12" name="TextBox 11"/>
+          <p:cNvSpPr txBox="1"/>
+          <p:nvPr/>
+        </p:nvSpPr>
+        <p:spPr>
+          <a:xfrm>
+            <a:off x="3200400" y="3154680"/>
+            <a:ext cx="1828800" cy="1097280"/>
+          </a:xfrm>
+          <a:prstGeom prst="rect">
+            <a:avLst/>
+          </a:prstGeom>
+          <a:noFill/>
+        </p:spPr>
+        <p:txBody>
+          <a:bodyPr wrap="square" anchor="t" lIns="45720" rIns="45720">
+            <a:spAutoFit/>
+          </a:bodyPr>
+          <a:lstStyle/>
+          <a:p>
+            <a:pPr algn="ctr"/>
+            <a:r>
+              <a:rPr sz="1500" b="0">
+                <a:solidFill>
+                  <a:srgbClr val="1F2A37"/>
+                </a:solidFill>
+                <a:latin typeface="Inter"/>
+              </a:rPr>
+              <a:t>Diabetes prevalence by region</a:t>
+            </a:r>
+          </a:p>
+        </p:txBody>
+      </p:sp>
+      <p:sp>
+        <p:nvSpPr>
+          <p:cNvPr id="13" name="TextBox 12"/>
+          <p:cNvSpPr txBox="1"/>
+          <p:nvPr/>
+        </p:nvSpPr>
+        <p:spPr>
+          <a:xfrm>
+            <a:off x="3200400" y="4206240"/>
+            <a:ext cx="1828800" cy="1005840"/>
+          </a:xfrm>
+          <a:prstGeom prst="rect">
+            <a:avLst/>
+          </a:prstGeom>
+          <a:noFill/>
+        </p:spPr>
+        <p:txBody>
+          <a:bodyPr wrap="square" anchor="t" lIns="45720" rIns="45720">
+            <a:spAutoFit/>
+          </a:bodyPr>
+          <a:lstStyle/>
+          <a:p>
+            <a:pPr algn="ctr"/>
+            <a:r>
+              <a:rPr sz="1500" b="1">
+                <a:solidFill>
+                  <a:srgbClr val="2E7D32"/>
+                </a:solidFill>
+                <a:latin typeface="Inter"/>
+              </a:rPr>
+              <a:t>Statistics, small cells hidden</a:t>
+            </a:r>
+          </a:p>
+        </p:txBody>
+      </p:sp>
+      <p:sp>
+        <p:nvSpPr>
+          <p:cNvPr id="14" name="Rounded Rectangle 13"/>
           <p:cNvSpPr/>
           <p:nvPr/>
         </p:nvSpPr>
         <p:spPr>
           <a:xfrm>
             <a:off x="5303520" y="2377440"/>
-            <a:ext cx="2103120" cy="640080"/>
+            <a:ext cx="2103120" cy="2926080"/>
           </a:xfrm>
           <a:prstGeom prst="roundRect">
             <a:avLst>
@@ -5961,7 +6731,7 @@
             </a:avLst>
           </a:prstGeom>
           <a:solidFill>
-            <a:srgbClr val="F0B429"/>
+            <a:srgbClr val="FFFFFF"/>
           </a:solidFill>
           <a:ln>
             <a:noFill/>
@@ -5992,119 +6762,14 @@
       </p:sp>
       <p:sp>
         <p:nvSpPr>
-          <p:cNvPr id="16" name="TextBox 15"/>
-          <p:cNvSpPr txBox="1"/>
+          <p:cNvPr id="15" name="Rounded Rectangle 14"/>
+          <p:cNvSpPr/>
           <p:nvPr/>
         </p:nvSpPr>
         <p:spPr>
           <a:xfrm>
             <a:off x="5303520" y="2377440"/>
             <a:ext cx="2103120" cy="640080"/>
-          </a:xfrm>
-          <a:prstGeom prst="rect">
-            <a:avLst/>
-          </a:prstGeom>
-          <a:noFill/>
-        </p:spPr>
-        <p:txBody>
-          <a:bodyPr wrap="square" anchor="ctr" lIns="45720" rIns="45720">
-            <a:spAutoFit/>
-          </a:bodyPr>
-          <a:lstStyle/>
-          <a:p>
-            <a:pPr algn="ctr"/>
-            <a:r>
-              <a:rPr sz="2000" b="1">
-                <a:solidFill>
-                  <a:srgbClr val="FFFFFF"/>
-                </a:solidFill>
-                <a:latin typeface="Inter"/>
-              </a:rPr>
-              <a:t>R11</a:t>
-            </a:r>
-          </a:p>
-        </p:txBody>
-      </p:sp>
-      <p:sp>
-        <p:nvSpPr>
-          <p:cNvPr id="17" name="TextBox 16"/>
-          <p:cNvSpPr txBox="1"/>
-          <p:nvPr/>
-        </p:nvSpPr>
-        <p:spPr>
-          <a:xfrm>
-            <a:off x="5440680" y="3154680"/>
-            <a:ext cx="1828800" cy="1097280"/>
-          </a:xfrm>
-          <a:prstGeom prst="rect">
-            <a:avLst/>
-          </a:prstGeom>
-          <a:noFill/>
-        </p:spPr>
-        <p:txBody>
-          <a:bodyPr wrap="square" anchor="t" lIns="45720" rIns="45720">
-            <a:spAutoFit/>
-          </a:bodyPr>
-          <a:lstStyle/>
-          <a:p>
-            <a:pPr algn="ctr"/>
-            <a:r>
-              <a:rPr sz="1500" b="0">
-                <a:solidFill>
-                  <a:srgbClr val="1F2A37"/>
-                </a:solidFill>
-                <a:latin typeface="Inter"/>
-              </a:rPr>
-              <a:t>Same, written in German</a:t>
-            </a:r>
-          </a:p>
-        </p:txBody>
-      </p:sp>
-      <p:sp>
-        <p:nvSpPr>
-          <p:cNvPr id="18" name="TextBox 17"/>
-          <p:cNvSpPr txBox="1"/>
-          <p:nvPr/>
-        </p:nvSpPr>
-        <p:spPr>
-          <a:xfrm>
-            <a:off x="5440680" y="4206240"/>
-            <a:ext cx="1828800" cy="1005840"/>
-          </a:xfrm>
-          <a:prstGeom prst="rect">
-            <a:avLst/>
-          </a:prstGeom>
-          <a:noFill/>
-        </p:spPr>
-        <p:txBody>
-          <a:bodyPr wrap="square" anchor="t" lIns="45720" rIns="45720">
-            <a:spAutoFit/>
-          </a:bodyPr>
-          <a:lstStyle/>
-          <a:p>
-            <a:pPr algn="ctr"/>
-            <a:r>
-              <a:rPr sz="1500" b="1">
-                <a:solidFill>
-                  <a:srgbClr val="F0B429"/>
-                </a:solidFill>
-                <a:latin typeface="Inter"/>
-              </a:rPr>
-              <a:t>Translated once, same rulebook</a:t>
-            </a:r>
-          </a:p>
-        </p:txBody>
-      </p:sp>
-      <p:sp>
-        <p:nvSpPr>
-          <p:cNvPr id="19" name="Rounded Rectangle 18"/>
-          <p:cNvSpPr/>
-          <p:nvPr/>
-        </p:nvSpPr>
-        <p:spPr>
-          <a:xfrm>
-            <a:off x="7543800" y="2377440"/>
-            <a:ext cx="2103120" cy="2926080"/>
           </a:xfrm>
           <a:prstGeom prst="roundRect">
             <a:avLst>
@@ -6112,7 +6777,7 @@
             </a:avLst>
           </a:prstGeom>
           <a:solidFill>
-            <a:srgbClr val="FFFFFF"/>
+            <a:srgbClr val="F0B429"/>
           </a:solidFill>
           <a:ln>
             <a:noFill/>
@@ -6143,14 +6808,119 @@
       </p:sp>
       <p:sp>
         <p:nvSpPr>
-          <p:cNvPr id="20" name="Rounded Rectangle 19"/>
+          <p:cNvPr id="16" name="TextBox 15"/>
+          <p:cNvSpPr txBox="1"/>
+          <p:nvPr/>
+        </p:nvSpPr>
+        <p:spPr>
+          <a:xfrm>
+            <a:off x="5303520" y="2377440"/>
+            <a:ext cx="2103120" cy="640080"/>
+          </a:xfrm>
+          <a:prstGeom prst="rect">
+            <a:avLst/>
+          </a:prstGeom>
+          <a:noFill/>
+        </p:spPr>
+        <p:txBody>
+          <a:bodyPr wrap="square" anchor="ctr" lIns="45720" rIns="45720">
+            <a:spAutoFit/>
+          </a:bodyPr>
+          <a:lstStyle/>
+          <a:p>
+            <a:pPr algn="ctr"/>
+            <a:r>
+              <a:rPr sz="2000" b="1">
+                <a:solidFill>
+                  <a:srgbClr val="FFFFFF"/>
+                </a:solidFill>
+                <a:latin typeface="Inter"/>
+              </a:rPr>
+              <a:t>R11</a:t>
+            </a:r>
+          </a:p>
+        </p:txBody>
+      </p:sp>
+      <p:sp>
+        <p:nvSpPr>
+          <p:cNvPr id="17" name="TextBox 16"/>
+          <p:cNvSpPr txBox="1"/>
+          <p:nvPr/>
+        </p:nvSpPr>
+        <p:spPr>
+          <a:xfrm>
+            <a:off x="5440680" y="3154680"/>
+            <a:ext cx="1828800" cy="1097280"/>
+          </a:xfrm>
+          <a:prstGeom prst="rect">
+            <a:avLst/>
+          </a:prstGeom>
+          <a:noFill/>
+        </p:spPr>
+        <p:txBody>
+          <a:bodyPr wrap="square" anchor="t" lIns="45720" rIns="45720">
+            <a:spAutoFit/>
+          </a:bodyPr>
+          <a:lstStyle/>
+          <a:p>
+            <a:pPr algn="ctr"/>
+            <a:r>
+              <a:rPr sz="1500" b="0">
+                <a:solidFill>
+                  <a:srgbClr val="1F2A37"/>
+                </a:solidFill>
+                <a:latin typeface="Inter"/>
+              </a:rPr>
+              <a:t>Same, written in German</a:t>
+            </a:r>
+          </a:p>
+        </p:txBody>
+      </p:sp>
+      <p:sp>
+        <p:nvSpPr>
+          <p:cNvPr id="18" name="TextBox 17"/>
+          <p:cNvSpPr txBox="1"/>
+          <p:nvPr/>
+        </p:nvSpPr>
+        <p:spPr>
+          <a:xfrm>
+            <a:off x="5440680" y="4206240"/>
+            <a:ext cx="1828800" cy="1005840"/>
+          </a:xfrm>
+          <a:prstGeom prst="rect">
+            <a:avLst/>
+          </a:prstGeom>
+          <a:noFill/>
+        </p:spPr>
+        <p:txBody>
+          <a:bodyPr wrap="square" anchor="t" lIns="45720" rIns="45720">
+            <a:spAutoFit/>
+          </a:bodyPr>
+          <a:lstStyle/>
+          <a:p>
+            <a:pPr algn="ctr"/>
+            <a:r>
+              <a:rPr sz="1500" b="1">
+                <a:solidFill>
+                  <a:srgbClr val="F0B429"/>
+                </a:solidFill>
+                <a:latin typeface="Inter"/>
+              </a:rPr>
+              <a:t>Translated once, same rulebook</a:t>
+            </a:r>
+          </a:p>
+        </p:txBody>
+      </p:sp>
+      <p:sp>
+        <p:nvSpPr>
+          <p:cNvPr id="19" name="Rounded Rectangle 18"/>
           <p:cNvSpPr/>
           <p:nvPr/>
         </p:nvSpPr>
         <p:spPr>
           <a:xfrm>
             <a:off x="7543800" y="2377440"/>
-            <a:ext cx="2103120" cy="640080"/>
+            <a:ext cx="2103120" cy="2926080"/>
           </a:xfrm>
           <a:prstGeom prst="roundRect">
             <a:avLst>
@@ -6158,7 +6928,7 @@
             </a:avLst>
           </a:prstGeom>
           <a:solidFill>
-            <a:srgbClr val="1565C0"/>
+            <a:srgbClr val="FFFFFF"/>
           </a:solidFill>
           <a:ln>
             <a:noFill/>
@@ -6189,119 +6959,14 @@
       </p:sp>
       <p:sp>
         <p:nvSpPr>
-          <p:cNvPr id="21" name="TextBox 20"/>
-          <p:cNvSpPr txBox="1"/>
+          <p:cNvPr id="20" name="Rounded Rectangle 19"/>
+          <p:cNvSpPr/>
           <p:nvPr/>
         </p:nvSpPr>
         <p:spPr>
           <a:xfrm>
             <a:off x="7543800" y="2377440"/>
             <a:ext cx="2103120" cy="640080"/>
-          </a:xfrm>
-          <a:prstGeom prst="rect">
-            <a:avLst/>
-          </a:prstGeom>
-          <a:noFill/>
-        </p:spPr>
-        <p:txBody>
-          <a:bodyPr wrap="square" anchor="ctr" lIns="45720" rIns="45720">
-            <a:spAutoFit/>
-          </a:bodyPr>
-          <a:lstStyle/>
-          <a:p>
-            <a:pPr algn="ctr"/>
-            <a:r>
-              <a:rPr sz="2000" b="1">
-                <a:solidFill>
-                  <a:srgbClr val="FFFFFF"/>
-                </a:solidFill>
-                <a:latin typeface="Inter"/>
-              </a:rPr>
-              <a:t>R12</a:t>
-            </a:r>
-          </a:p>
-        </p:txBody>
-      </p:sp>
-      <p:sp>
-        <p:nvSpPr>
-          <p:cNvPr id="22" name="TextBox 21"/>
-          <p:cNvSpPr txBox="1"/>
-          <p:nvPr/>
-        </p:nvSpPr>
-        <p:spPr>
-          <a:xfrm>
-            <a:off x="7680960" y="3154680"/>
-            <a:ext cx="1828800" cy="1097280"/>
-          </a:xfrm>
-          <a:prstGeom prst="rect">
-            <a:avLst/>
-          </a:prstGeom>
-          <a:noFill/>
-        </p:spPr>
-        <p:txBody>
-          <a:bodyPr wrap="square" anchor="t" lIns="45720" rIns="45720">
-            <a:spAutoFit/>
-          </a:bodyPr>
-          <a:lstStyle/>
-          <a:p>
-            <a:pPr algn="ctr"/>
-            <a:r>
-              <a:rPr sz="1500" b="0">
-                <a:solidFill>
-                  <a:srgbClr val="1F2A37"/>
-                </a:solidFill>
-                <a:latin typeface="Inter"/>
-              </a:rPr>
-              <a:t>Heart-failure records for a model</a:t>
-            </a:r>
-          </a:p>
-        </p:txBody>
-      </p:sp>
-      <p:sp>
-        <p:nvSpPr>
-          <p:cNvPr id="23" name="TextBox 22"/>
-          <p:cNvSpPr txBox="1"/>
-          <p:nvPr/>
-        </p:nvSpPr>
-        <p:spPr>
-          <a:xfrm>
-            <a:off x="7680960" y="4206240"/>
-            <a:ext cx="1828800" cy="1005840"/>
-          </a:xfrm>
-          <a:prstGeom prst="rect">
-            <a:avLst/>
-          </a:prstGeom>
-          <a:noFill/>
-        </p:spPr>
-        <p:txBody>
-          <a:bodyPr wrap="square" anchor="t" lIns="45720" rIns="45720">
-            <a:spAutoFit/>
-          </a:bodyPr>
-          <a:lstStyle/>
-          <a:p>
-            <a:pPr algn="ctr"/>
-            <a:r>
-              <a:rPr sz="1500" b="1">
-                <a:solidFill>
-                  <a:srgbClr val="1565C0"/>
-                </a:solidFill>
-                <a:latin typeface="Inter"/>
-              </a:rPr>
-              <a:t>Secure room, download → 403</a:t>
-            </a:r>
-          </a:p>
-        </p:txBody>
-      </p:sp>
-      <p:sp>
-        <p:nvSpPr>
-          <p:cNvPr id="24" name="Rounded Rectangle 23"/>
-          <p:cNvSpPr/>
-          <p:nvPr/>
-        </p:nvSpPr>
-        <p:spPr>
-          <a:xfrm>
-            <a:off x="9784080" y="2377440"/>
-            <a:ext cx="2103120" cy="2926080"/>
           </a:xfrm>
           <a:prstGeom prst="roundRect">
             <a:avLst>
@@ -6309,7 +6974,7 @@
             </a:avLst>
           </a:prstGeom>
           <a:solidFill>
-            <a:srgbClr val="FFFFFF"/>
+            <a:srgbClr val="1565C0"/>
           </a:solidFill>
           <a:ln>
             <a:noFill/>
@@ -6340,14 +7005,119 @@
       </p:sp>
       <p:sp>
         <p:nvSpPr>
-          <p:cNvPr id="25" name="Rounded Rectangle 24"/>
+          <p:cNvPr id="21" name="TextBox 20"/>
+          <p:cNvSpPr txBox="1"/>
+          <p:nvPr/>
+        </p:nvSpPr>
+        <p:spPr>
+          <a:xfrm>
+            <a:off x="7543800" y="2377440"/>
+            <a:ext cx="2103120" cy="640080"/>
+          </a:xfrm>
+          <a:prstGeom prst="rect">
+            <a:avLst/>
+          </a:prstGeom>
+          <a:noFill/>
+        </p:spPr>
+        <p:txBody>
+          <a:bodyPr wrap="square" anchor="ctr" lIns="45720" rIns="45720">
+            <a:spAutoFit/>
+          </a:bodyPr>
+          <a:lstStyle/>
+          <a:p>
+            <a:pPr algn="ctr"/>
+            <a:r>
+              <a:rPr sz="2000" b="1">
+                <a:solidFill>
+                  <a:srgbClr val="FFFFFF"/>
+                </a:solidFill>
+                <a:latin typeface="Inter"/>
+              </a:rPr>
+              <a:t>R12</a:t>
+            </a:r>
+          </a:p>
+        </p:txBody>
+      </p:sp>
+      <p:sp>
+        <p:nvSpPr>
+          <p:cNvPr id="22" name="TextBox 21"/>
+          <p:cNvSpPr txBox="1"/>
+          <p:nvPr/>
+        </p:nvSpPr>
+        <p:spPr>
+          <a:xfrm>
+            <a:off x="7680960" y="3154680"/>
+            <a:ext cx="1828800" cy="1097280"/>
+          </a:xfrm>
+          <a:prstGeom prst="rect">
+            <a:avLst/>
+          </a:prstGeom>
+          <a:noFill/>
+        </p:spPr>
+        <p:txBody>
+          <a:bodyPr wrap="square" anchor="t" lIns="45720" rIns="45720">
+            <a:spAutoFit/>
+          </a:bodyPr>
+          <a:lstStyle/>
+          <a:p>
+            <a:pPr algn="ctr"/>
+            <a:r>
+              <a:rPr sz="1500" b="0">
+                <a:solidFill>
+                  <a:srgbClr val="1F2A37"/>
+                </a:solidFill>
+                <a:latin typeface="Inter"/>
+              </a:rPr>
+              <a:t>Heart-failure records for a model</a:t>
+            </a:r>
+          </a:p>
+        </p:txBody>
+      </p:sp>
+      <p:sp>
+        <p:nvSpPr>
+          <p:cNvPr id="23" name="TextBox 22"/>
+          <p:cNvSpPr txBox="1"/>
+          <p:nvPr/>
+        </p:nvSpPr>
+        <p:spPr>
+          <a:xfrm>
+            <a:off x="7680960" y="4206240"/>
+            <a:ext cx="1828800" cy="1005840"/>
+          </a:xfrm>
+          <a:prstGeom prst="rect">
+            <a:avLst/>
+          </a:prstGeom>
+          <a:noFill/>
+        </p:spPr>
+        <p:txBody>
+          <a:bodyPr wrap="square" anchor="t" lIns="45720" rIns="45720">
+            <a:spAutoFit/>
+          </a:bodyPr>
+          <a:lstStyle/>
+          <a:p>
+            <a:pPr algn="ctr"/>
+            <a:r>
+              <a:rPr sz="1500" b="1">
+                <a:solidFill>
+                  <a:srgbClr val="1565C0"/>
+                </a:solidFill>
+                <a:latin typeface="Inter"/>
+              </a:rPr>
+              <a:t>Secure room, download → 403</a:t>
+            </a:r>
+          </a:p>
+        </p:txBody>
+      </p:sp>
+      <p:sp>
+        <p:nvSpPr>
+          <p:cNvPr id="24" name="Rounded Rectangle 23"/>
           <p:cNvSpPr/>
           <p:nvPr/>
         </p:nvSpPr>
         <p:spPr>
           <a:xfrm>
             <a:off x="9784080" y="2377440"/>
-            <a:ext cx="2103120" cy="640080"/>
+            <a:ext cx="2103120" cy="2926080"/>
           </a:xfrm>
           <a:prstGeom prst="roundRect">
             <a:avLst>
@@ -6355,7 +7125,7 @@
             </a:avLst>
           </a:prstGeom>
           <a:solidFill>
-            <a:srgbClr val="C62828"/>
+            <a:srgbClr val="FFFFFF"/>
           </a:solidFill>
           <a:ln>
             <a:noFill/>
@@ -6386,6 +7156,52 @@
       </p:sp>
       <p:sp>
         <p:nvSpPr>
+          <p:cNvPr id="25" name="Rounded Rectangle 24"/>
+          <p:cNvSpPr/>
+          <p:nvPr/>
+        </p:nvSpPr>
+        <p:spPr>
+          <a:xfrm>
+            <a:off x="9784080" y="2377440"/>
+            <a:ext cx="2103120" cy="640080"/>
+          </a:xfrm>
+          <a:prstGeom prst="roundRect">
+            <a:avLst>
+              <a:gd name="adj" fmla="val 8000"/>
+            </a:avLst>
+          </a:prstGeom>
+          <a:solidFill>
+            <a:srgbClr val="C62828"/>
+          </a:solidFill>
+          <a:ln>
+            <a:noFill/>
+          </a:ln>
+          <a:effectLst/>
+        </p:spPr>
+        <p:style>
+          <a:lnRef idx="1">
+            <a:schemeClr val="accent1"/>
+          </a:lnRef>
+          <a:fillRef idx="3">
+            <a:schemeClr val="accent1"/>
+          </a:fillRef>
+          <a:effectRef idx="2">
+            <a:schemeClr val="accent1"/>
+          </a:effectRef>
+          <a:fontRef idx="minor">
+            <a:schemeClr val="lt1"/>
+          </a:fontRef>
+        </p:style>
+        <p:txBody>
+          <a:bodyPr rtlCol="0" anchor="ctr"/>
+          <a:lstStyle/>
+          <a:p>
+            <a:pPr algn="ctr"/>
+          </a:p>
+        </p:txBody>
+      </p:sp>
+      <p:sp>
+        <p:nvSpPr>
           <p:cNvPr id="26" name="TextBox 25"/>
           <p:cNvSpPr txBox="1"/>
           <p:nvPr/>
@@ -6532,7 +7348,7 @@
 </p:sld>
 </file>
 
-<file path=ppt/slides/slide6.xml><?xml version="1.0" encoding="utf-8"?>
+<file path=ppt/slides/slide7.xml><?xml version="1.0" encoding="utf-8"?>
 <p:sld xmlns:a="http://schemas.openxmlformats.org/drawingml/2006/main" xmlns:p="http://schemas.openxmlformats.org/presentationml/2006/main" xmlns:r="http://schemas.openxmlformats.org/officeDocument/2006/relationships">
   <p:cSld>
     <p:spTree>

</xml_diff>

<commit_message>
Pitch deck: approach slide reduced to four ideas
Generated with [Devin](https://devin.ai)

Co-Authored-By: Devin <158243242+devin-ai-integration[bot]@users.noreply.github.com>
</commit_message>
<xml_diff>
--- a/docs/slides/pitch.pptx
+++ b/docs/slides/pitch.pptx
@@ -648,7 +648,7 @@
           <a:lstStyle/>
           <a:p>
             <a:r>
-              <a:t>So what did we do about it? Researchers write the request in plain words, in any EU language, and if they cannot phrase the definitions, one click drafts them. Engineers are out of the loop: fixed rules turn the definitions into SQL, and an AI only steps in where the rules give up, under the same checks. And the access body gets a decision that quotes the article from the regulation, with the privacy rules enforced inside the query and records locked in a secure room. Seconds instead of weeks, and the same answer every time. (≈25 s)</a:t>
+              <a:t>Four ideas. The AI does not decide on its own: it picks the article from the regulation and has to quote it. Definitions become SQL through fixed rules, so no one writes a query per request and the numbers are the same every run. Privacy lives inside the query: small cells and opt-outs cannot leak. And records never leave the secure room: viewed as images, never downloaded. (≈20 s)</a:t>
             </a:r>
           </a:p>
         </p:txBody>
@@ -4945,7 +4945,7 @@
                 </a:solidFill>
                 <a:latin typeface="Inter"/>
               </a:rPr>
-              <a:t>What we did about it</a:t>
+              <a:t>Our approach</a:t>
             </a:r>
           </a:p>
         </p:txBody>
@@ -4980,7 +4980,7 @@
                 </a:solidFill>
                 <a:latin typeface="Inter"/>
               </a:rPr>
-              <a:t>the same three people, one app</a:t>
+              <a:t>four ideas</a:t>
             </a:r>
           </a:p>
         </p:txBody>
@@ -5028,8 +5028,336 @@
         </p:nvSpPr>
         <p:spPr>
           <a:xfrm>
-            <a:off x="548640" y="1371600"/>
-            <a:ext cx="3474720" cy="3566160"/>
+            <a:off x="548640" y="1417320"/>
+            <a:ext cx="5394960" cy="2103120"/>
+          </a:xfrm>
+          <a:prstGeom prst="roundRect">
+            <a:avLst>
+              <a:gd name="adj" fmla="val 8000"/>
+            </a:avLst>
+          </a:prstGeom>
+          <a:solidFill>
+            <a:srgbClr val="F6F7F9"/>
+          </a:solidFill>
+          <a:ln w="19050">
+            <a:solidFill>
+              <a:srgbClr val="F0B429"/>
+            </a:solidFill>
+          </a:ln>
+          <a:effectLst/>
+        </p:spPr>
+        <p:style>
+          <a:lnRef idx="1">
+            <a:schemeClr val="accent1"/>
+          </a:lnRef>
+          <a:fillRef idx="3">
+            <a:schemeClr val="accent1"/>
+          </a:fillRef>
+          <a:effectRef idx="2">
+            <a:schemeClr val="accent1"/>
+          </a:effectRef>
+          <a:fontRef idx="minor">
+            <a:schemeClr val="lt1"/>
+          </a:fontRef>
+        </p:style>
+        <p:txBody>
+          <a:bodyPr rtlCol="0" anchor="ctr"/>
+          <a:lstStyle/>
+          <a:p>
+            <a:pPr algn="ctr"/>
+          </a:p>
+        </p:txBody>
+      </p:sp>
+      <p:sp>
+        <p:nvSpPr>
+          <p:cNvPr id="7" name="Rounded Rectangle 6"/>
+          <p:cNvSpPr/>
+          <p:nvPr/>
+        </p:nvSpPr>
+        <p:spPr>
+          <a:xfrm>
+            <a:off x="548640" y="1417320"/>
+            <a:ext cx="164592" cy="2103120"/>
+          </a:xfrm>
+          <a:prstGeom prst="roundRect">
+            <a:avLst>
+              <a:gd name="adj" fmla="val 8000"/>
+            </a:avLst>
+          </a:prstGeom>
+          <a:solidFill>
+            <a:srgbClr val="F0B429"/>
+          </a:solidFill>
+          <a:ln>
+            <a:noFill/>
+          </a:ln>
+          <a:effectLst/>
+        </p:spPr>
+        <p:style>
+          <a:lnRef idx="1">
+            <a:schemeClr val="accent1"/>
+          </a:lnRef>
+          <a:fillRef idx="3">
+            <a:schemeClr val="accent1"/>
+          </a:fillRef>
+          <a:effectRef idx="2">
+            <a:schemeClr val="accent1"/>
+          </a:effectRef>
+          <a:fontRef idx="minor">
+            <a:schemeClr val="lt1"/>
+          </a:fontRef>
+        </p:style>
+        <p:txBody>
+          <a:bodyPr rtlCol="0" anchor="ctr"/>
+          <a:lstStyle/>
+          <a:p>
+            <a:pPr algn="ctr"/>
+          </a:p>
+        </p:txBody>
+      </p:sp>
+      <p:sp>
+        <p:nvSpPr>
+          <p:cNvPr id="8" name="TextBox 7"/>
+          <p:cNvSpPr txBox="1"/>
+          <p:nvPr/>
+        </p:nvSpPr>
+        <p:spPr>
+          <a:xfrm>
+            <a:off x="1005840" y="1828800"/>
+            <a:ext cx="4663440" cy="731520"/>
+          </a:xfrm>
+          <a:prstGeom prst="rect">
+            <a:avLst/>
+          </a:prstGeom>
+          <a:noFill/>
+        </p:spPr>
+        <p:txBody>
+          <a:bodyPr wrap="square" anchor="t" lIns="45720" rIns="45720">
+            <a:spAutoFit/>
+          </a:bodyPr>
+          <a:lstStyle/>
+          <a:p>
+            <a:pPr algn="l"/>
+            <a:r>
+              <a:rPr sz="2800" b="1">
+                <a:solidFill>
+                  <a:srgbClr val="F0B429"/>
+                </a:solidFill>
+                <a:latin typeface="Inter"/>
+              </a:rPr>
+              <a:t>Law-grounded AI</a:t>
+            </a:r>
+          </a:p>
+        </p:txBody>
+      </p:sp>
+      <p:sp>
+        <p:nvSpPr>
+          <p:cNvPr id="9" name="TextBox 8"/>
+          <p:cNvSpPr txBox="1"/>
+          <p:nvPr/>
+        </p:nvSpPr>
+        <p:spPr>
+          <a:xfrm>
+            <a:off x="1005840" y="2606040"/>
+            <a:ext cx="4663440" cy="548640"/>
+          </a:xfrm>
+          <a:prstGeom prst="rect">
+            <a:avLst/>
+          </a:prstGeom>
+          <a:noFill/>
+        </p:spPr>
+        <p:txBody>
+          <a:bodyPr wrap="square" anchor="t" lIns="45720" rIns="45720">
+            <a:spAutoFit/>
+          </a:bodyPr>
+          <a:lstStyle/>
+          <a:p>
+            <a:pPr algn="l"/>
+            <a:r>
+              <a:rPr sz="1700" b="0">
+                <a:solidFill>
+                  <a:srgbClr val="5B6472"/>
+                </a:solidFill>
+                <a:latin typeface="Inter"/>
+              </a:rPr>
+              <a:t>picks the article and quotes it</a:t>
+            </a:r>
+          </a:p>
+        </p:txBody>
+      </p:sp>
+      <p:sp>
+        <p:nvSpPr>
+          <p:cNvPr id="10" name="Rounded Rectangle 9"/>
+          <p:cNvSpPr/>
+          <p:nvPr/>
+        </p:nvSpPr>
+        <p:spPr>
+          <a:xfrm>
+            <a:off x="6263640" y="1417320"/>
+            <a:ext cx="5394960" cy="2103120"/>
+          </a:xfrm>
+          <a:prstGeom prst="roundRect">
+            <a:avLst>
+              <a:gd name="adj" fmla="val 8000"/>
+            </a:avLst>
+          </a:prstGeom>
+          <a:solidFill>
+            <a:srgbClr val="F6F7F9"/>
+          </a:solidFill>
+          <a:ln w="19050">
+            <a:solidFill>
+              <a:srgbClr val="2E7D32"/>
+            </a:solidFill>
+          </a:ln>
+          <a:effectLst/>
+        </p:spPr>
+        <p:style>
+          <a:lnRef idx="1">
+            <a:schemeClr val="accent1"/>
+          </a:lnRef>
+          <a:fillRef idx="3">
+            <a:schemeClr val="accent1"/>
+          </a:fillRef>
+          <a:effectRef idx="2">
+            <a:schemeClr val="accent1"/>
+          </a:effectRef>
+          <a:fontRef idx="minor">
+            <a:schemeClr val="lt1"/>
+          </a:fontRef>
+        </p:style>
+        <p:txBody>
+          <a:bodyPr rtlCol="0" anchor="ctr"/>
+          <a:lstStyle/>
+          <a:p>
+            <a:pPr algn="ctr"/>
+          </a:p>
+        </p:txBody>
+      </p:sp>
+      <p:sp>
+        <p:nvSpPr>
+          <p:cNvPr id="11" name="Rounded Rectangle 10"/>
+          <p:cNvSpPr/>
+          <p:nvPr/>
+        </p:nvSpPr>
+        <p:spPr>
+          <a:xfrm>
+            <a:off x="6263640" y="1417320"/>
+            <a:ext cx="164592" cy="2103120"/>
+          </a:xfrm>
+          <a:prstGeom prst="roundRect">
+            <a:avLst>
+              <a:gd name="adj" fmla="val 8000"/>
+            </a:avLst>
+          </a:prstGeom>
+          <a:solidFill>
+            <a:srgbClr val="2E7D32"/>
+          </a:solidFill>
+          <a:ln>
+            <a:noFill/>
+          </a:ln>
+          <a:effectLst/>
+        </p:spPr>
+        <p:style>
+          <a:lnRef idx="1">
+            <a:schemeClr val="accent1"/>
+          </a:lnRef>
+          <a:fillRef idx="3">
+            <a:schemeClr val="accent1"/>
+          </a:fillRef>
+          <a:effectRef idx="2">
+            <a:schemeClr val="accent1"/>
+          </a:effectRef>
+          <a:fontRef idx="minor">
+            <a:schemeClr val="lt1"/>
+          </a:fontRef>
+        </p:style>
+        <p:txBody>
+          <a:bodyPr rtlCol="0" anchor="ctr"/>
+          <a:lstStyle/>
+          <a:p>
+            <a:pPr algn="ctr"/>
+          </a:p>
+        </p:txBody>
+      </p:sp>
+      <p:sp>
+        <p:nvSpPr>
+          <p:cNvPr id="12" name="TextBox 11"/>
+          <p:cNvSpPr txBox="1"/>
+          <p:nvPr/>
+        </p:nvSpPr>
+        <p:spPr>
+          <a:xfrm>
+            <a:off x="6720840" y="1828800"/>
+            <a:ext cx="4663440" cy="731520"/>
+          </a:xfrm>
+          <a:prstGeom prst="rect">
+            <a:avLst/>
+          </a:prstGeom>
+          <a:noFill/>
+        </p:spPr>
+        <p:txBody>
+          <a:bodyPr wrap="square" anchor="t" lIns="45720" rIns="45720">
+            <a:spAutoFit/>
+          </a:bodyPr>
+          <a:lstStyle/>
+          <a:p>
+            <a:pPr algn="l"/>
+            <a:r>
+              <a:rPr sz="2800" b="1">
+                <a:solidFill>
+                  <a:srgbClr val="2E7D32"/>
+                </a:solidFill>
+                <a:latin typeface="Inter"/>
+              </a:rPr>
+              <a:t>Words → SQL by rules</a:t>
+            </a:r>
+          </a:p>
+        </p:txBody>
+      </p:sp>
+      <p:sp>
+        <p:nvSpPr>
+          <p:cNvPr id="13" name="TextBox 12"/>
+          <p:cNvSpPr txBox="1"/>
+          <p:nvPr/>
+        </p:nvSpPr>
+        <p:spPr>
+          <a:xfrm>
+            <a:off x="6720840" y="2606040"/>
+            <a:ext cx="4663440" cy="548640"/>
+          </a:xfrm>
+          <a:prstGeom prst="rect">
+            <a:avLst/>
+          </a:prstGeom>
+          <a:noFill/>
+        </p:spPr>
+        <p:txBody>
+          <a:bodyPr wrap="square" anchor="t" lIns="45720" rIns="45720">
+            <a:spAutoFit/>
+          </a:bodyPr>
+          <a:lstStyle/>
+          <a:p>
+            <a:pPr algn="l"/>
+            <a:r>
+              <a:rPr sz="1700" b="0">
+                <a:solidFill>
+                  <a:srgbClr val="5B6472"/>
+                </a:solidFill>
+                <a:latin typeface="Inter"/>
+              </a:rPr>
+              <a:t>no query written per request</a:t>
+            </a:r>
+          </a:p>
+        </p:txBody>
+      </p:sp>
+      <p:sp>
+        <p:nvSpPr>
+          <p:cNvPr id="14" name="Rounded Rectangle 13"/>
+          <p:cNvSpPr/>
+          <p:nvPr/>
+        </p:nvSpPr>
+        <p:spPr>
+          <a:xfrm>
+            <a:off x="548640" y="3794760"/>
+            <a:ext cx="5394960" cy="2103120"/>
           </a:xfrm>
           <a:prstGeom prst="roundRect">
             <a:avLst>
@@ -5070,120 +5398,14 @@
       </p:sp>
       <p:sp>
         <p:nvSpPr>
-          <p:cNvPr id="7" name="TextBox 6"/>
-          <p:cNvSpPr txBox="1"/>
-          <p:nvPr/>
-        </p:nvSpPr>
-        <p:spPr>
-          <a:xfrm>
-            <a:off x="777240" y="1554480"/>
-            <a:ext cx="3017520" cy="457200"/>
-          </a:xfrm>
-          <a:prstGeom prst="rect">
-            <a:avLst/>
-          </a:prstGeom>
-          <a:noFill/>
-        </p:spPr>
-        <p:txBody>
-          <a:bodyPr wrap="square" anchor="t" lIns="45720" rIns="45720">
-            <a:spAutoFit/>
-          </a:bodyPr>
-          <a:lstStyle/>
-          <a:p>
-            <a:pPr algn="l"/>
-            <a:r>
-              <a:rPr sz="2000" b="1">
-                <a:solidFill>
-                  <a:srgbClr val="1565C0"/>
-                </a:solidFill>
-                <a:latin typeface="Inter"/>
-              </a:rPr>
-              <a:t>Researchers</a:t>
-            </a:r>
-          </a:p>
-        </p:txBody>
-      </p:sp>
-      <p:sp>
-        <p:nvSpPr>
-          <p:cNvPr id="8" name="TextBox 7"/>
-          <p:cNvSpPr txBox="1"/>
-          <p:nvPr/>
-        </p:nvSpPr>
-        <p:spPr>
-          <a:xfrm>
-            <a:off x="777240" y="2103120"/>
-            <a:ext cx="3017520" cy="2651760"/>
-          </a:xfrm>
-          <a:prstGeom prst="rect">
-            <a:avLst/>
-          </a:prstGeom>
-          <a:noFill/>
-        </p:spPr>
-        <p:txBody>
-          <a:bodyPr wrap="square">
-            <a:spAutoFit/>
-          </a:bodyPr>
-          <a:lstStyle/>
-          <a:p>
-            <a:pPr>
-              <a:spcAft>
-                <a:spcPts val="800"/>
-              </a:spcAft>
-            </a:pPr>
-            <a:r>
-              <a:rPr sz="1500" b="1">
-                <a:solidFill>
-                  <a:srgbClr val="1F2A37"/>
-                </a:solidFill>
-                <a:latin typeface="Inter"/>
-              </a:rPr>
-              <a:t>•  write the request in plain words, in any EU language</a:t>
-            </a:r>
-          </a:p>
-          <a:p>
-            <a:pPr>
-              <a:spcAft>
-                <a:spcPts val="800"/>
-              </a:spcAft>
-            </a:pPr>
-            <a:r>
-              <a:rPr sz="1500" b="1">
-                <a:solidFill>
-                  <a:srgbClr val="1F2A37"/>
-                </a:solidFill>
-                <a:latin typeface="Inter"/>
-              </a:rPr>
-              <a:t>•  one click: the AI drafts the definitions they could not phrase</a:t>
-            </a:r>
-          </a:p>
-          <a:p>
-            <a:pPr>
-              <a:spcAft>
-                <a:spcPts val="800"/>
-              </a:spcAft>
-            </a:pPr>
-            <a:r>
-              <a:rPr sz="1500" b="1">
-                <a:solidFill>
-                  <a:srgbClr val="1F2A37"/>
-                </a:solidFill>
-                <a:latin typeface="Inter"/>
-              </a:rPr>
-              <a:t>•  the answer comes back in seconds, with the reason</a:t>
-            </a:r>
-          </a:p>
-        </p:txBody>
-      </p:sp>
-      <p:sp>
-        <p:nvSpPr>
-          <p:cNvPr id="9" name="Rounded Rectangle 8"/>
+          <p:cNvPr id="15" name="Rounded Rectangle 14"/>
           <p:cNvSpPr/>
           <p:nvPr/>
         </p:nvSpPr>
         <p:spPr>
           <a:xfrm>
-            <a:off x="4343400" y="1371600"/>
-            <a:ext cx="3474720" cy="3566160"/>
+            <a:off x="548640" y="3794760"/>
+            <a:ext cx="164592" cy="2103120"/>
           </a:xfrm>
           <a:prstGeom prst="roundRect">
             <a:avLst>
@@ -5191,12 +5413,10 @@
             </a:avLst>
           </a:prstGeom>
           <a:solidFill>
-            <a:srgbClr val="F6F7F9"/>
+            <a:srgbClr val="1565C0"/>
           </a:solidFill>
-          <a:ln w="19050">
-            <a:solidFill>
-              <a:srgbClr val="F0B429"/>
-            </a:solidFill>
+          <a:ln>
+            <a:noFill/>
           </a:ln>
           <a:effectLst/>
         </p:spPr>
@@ -5224,14 +5444,14 @@
       </p:sp>
       <p:sp>
         <p:nvSpPr>
-          <p:cNvPr id="10" name="TextBox 9"/>
+          <p:cNvPr id="16" name="TextBox 15"/>
           <p:cNvSpPr txBox="1"/>
           <p:nvPr/>
         </p:nvSpPr>
         <p:spPr>
           <a:xfrm>
-            <a:off x="4572000" y="1554480"/>
-            <a:ext cx="3017520" cy="457200"/>
+            <a:off x="1005840" y="4206240"/>
+            <a:ext cx="4663440" cy="731520"/>
           </a:xfrm>
           <a:prstGeom prst="rect">
             <a:avLst/>
@@ -5246,27 +5466,27 @@
           <a:p>
             <a:pPr algn="l"/>
             <a:r>
-              <a:rPr sz="2000" b="1">
-                <a:solidFill>
-                  <a:srgbClr val="F0B429"/>
-                </a:solidFill>
-                <a:latin typeface="Inter"/>
-              </a:rPr>
-              <a:t>Engineers</a:t>
-            </a:r>
-          </a:p>
-        </p:txBody>
-      </p:sp>
-      <p:sp>
-        <p:nvSpPr>
-          <p:cNvPr id="11" name="TextBox 10"/>
+              <a:rPr sz="2800" b="1">
+                <a:solidFill>
+                  <a:srgbClr val="1565C0"/>
+                </a:solidFill>
+                <a:latin typeface="Inter"/>
+              </a:rPr>
+              <a:t>Privacy inside the query</a:t>
+            </a:r>
+          </a:p>
+        </p:txBody>
+      </p:sp>
+      <p:sp>
+        <p:nvSpPr>
+          <p:cNvPr id="17" name="TextBox 16"/>
           <p:cNvSpPr txBox="1"/>
           <p:nvPr/>
         </p:nvSpPr>
         <p:spPr>
           <a:xfrm>
-            <a:off x="4572000" y="2103120"/>
-            <a:ext cx="3017520" cy="2651760"/>
+            <a:off x="1005840" y="4983480"/>
+            <a:ext cx="4663440" cy="548640"/>
           </a:xfrm>
           <a:prstGeom prst="rect">
             <a:avLst/>
@@ -5274,70 +5494,34 @@
           <a:noFill/>
         </p:spPr>
         <p:txBody>
-          <a:bodyPr wrap="square">
+          <a:bodyPr wrap="square" anchor="t" lIns="45720" rIns="45720">
             <a:spAutoFit/>
           </a:bodyPr>
           <a:lstStyle/>
           <a:p>
-            <a:pPr>
-              <a:spcAft>
-                <a:spcPts val="800"/>
-              </a:spcAft>
-            </a:pPr>
-            <a:r>
-              <a:rPr sz="1500" b="1">
-                <a:solidFill>
-                  <a:srgbClr val="1F2A37"/>
-                </a:solidFill>
-                <a:latin typeface="Inter"/>
-              </a:rPr>
-              <a:t>•  no one writes a query per request</a:t>
-            </a:r>
-          </a:p>
-          <a:p>
-            <a:pPr>
-              <a:spcAft>
-                <a:spcPts val="800"/>
-              </a:spcAft>
-            </a:pPr>
-            <a:r>
-              <a:rPr sz="1500" b="1">
-                <a:solidFill>
-                  <a:srgbClr val="1F2A37"/>
-                </a:solidFill>
-                <a:latin typeface="Inter"/>
-              </a:rPr>
-              <a:t>•  fixed rules turn the definitions into SQL; codes come from the request</a:t>
-            </a:r>
-          </a:p>
-          <a:p>
-            <a:pPr>
-              <a:spcAft>
-                <a:spcPts val="800"/>
-              </a:spcAft>
-            </a:pPr>
-            <a:r>
-              <a:rPr sz="1500" b="1">
-                <a:solidFill>
-                  <a:srgbClr val="1F2A37"/>
-                </a:solidFill>
-                <a:latin typeface="Inter"/>
-              </a:rPr>
-              <a:t>•  an LLM steps in only where the rules give up, under the same checks</a:t>
-            </a:r>
-          </a:p>
-        </p:txBody>
-      </p:sp>
-      <p:sp>
-        <p:nvSpPr>
-          <p:cNvPr id="12" name="Rounded Rectangle 11"/>
+            <a:pPr algn="l"/>
+            <a:r>
+              <a:rPr sz="1700" b="0">
+                <a:solidFill>
+                  <a:srgbClr val="5B6472"/>
+                </a:solidFill>
+                <a:latin typeface="Inter"/>
+              </a:rPr>
+              <a:t>small cells and opt-outs cannot leak</a:t>
+            </a:r>
+          </a:p>
+        </p:txBody>
+      </p:sp>
+      <p:sp>
+        <p:nvSpPr>
+          <p:cNvPr id="18" name="Rounded Rectangle 17"/>
           <p:cNvSpPr/>
           <p:nvPr/>
         </p:nvSpPr>
         <p:spPr>
           <a:xfrm>
-            <a:off x="8138160" y="1371600"/>
-            <a:ext cx="3474720" cy="3566160"/>
+            <a:off x="6263640" y="3794760"/>
+            <a:ext cx="5394960" cy="2103120"/>
           </a:xfrm>
           <a:prstGeom prst="roundRect">
             <a:avLst>
@@ -5378,120 +5562,14 @@
       </p:sp>
       <p:sp>
         <p:nvSpPr>
-          <p:cNvPr id="13" name="TextBox 12"/>
-          <p:cNvSpPr txBox="1"/>
-          <p:nvPr/>
-        </p:nvSpPr>
-        <p:spPr>
-          <a:xfrm>
-            <a:off x="8366760" y="1554480"/>
-            <a:ext cx="3017520" cy="457200"/>
-          </a:xfrm>
-          <a:prstGeom prst="rect">
-            <a:avLst/>
-          </a:prstGeom>
-          <a:noFill/>
-        </p:spPr>
-        <p:txBody>
-          <a:bodyPr wrap="square" anchor="t" lIns="45720" rIns="45720">
-            <a:spAutoFit/>
-          </a:bodyPr>
-          <a:lstStyle/>
-          <a:p>
-            <a:pPr algn="l"/>
-            <a:r>
-              <a:rPr sz="2000" b="1">
-                <a:solidFill>
-                  <a:srgbClr val="C62828"/>
-                </a:solidFill>
-                <a:latin typeface="Inter"/>
-              </a:rPr>
-              <a:t>The access body</a:t>
-            </a:r>
-          </a:p>
-        </p:txBody>
-      </p:sp>
-      <p:sp>
-        <p:nvSpPr>
-          <p:cNvPr id="14" name="TextBox 13"/>
-          <p:cNvSpPr txBox="1"/>
-          <p:nvPr/>
-        </p:nvSpPr>
-        <p:spPr>
-          <a:xfrm>
-            <a:off x="8366760" y="2103120"/>
-            <a:ext cx="3017520" cy="2651760"/>
-          </a:xfrm>
-          <a:prstGeom prst="rect">
-            <a:avLst/>
-          </a:prstGeom>
-          <a:noFill/>
-        </p:spPr>
-        <p:txBody>
-          <a:bodyPr wrap="square">
-            <a:spAutoFit/>
-          </a:bodyPr>
-          <a:lstStyle/>
-          <a:p>
-            <a:pPr>
-              <a:spcAft>
-                <a:spcPts val="800"/>
-              </a:spcAft>
-            </a:pPr>
-            <a:r>
-              <a:rPr sz="1500" b="1">
-                <a:solidFill>
-                  <a:srgbClr val="1F2A37"/>
-                </a:solidFill>
-                <a:latin typeface="Inter"/>
-              </a:rPr>
-              <a:t>•  the law check quotes the article, verbatim from the regulation</a:t>
-            </a:r>
-          </a:p>
-          <a:p>
-            <a:pPr>
-              <a:spcAft>
-                <a:spcPts val="800"/>
-              </a:spcAft>
-            </a:pPr>
-            <a:r>
-              <a:rPr sz="1500" b="1">
-                <a:solidFill>
-                  <a:srgbClr val="1F2A37"/>
-                </a:solidFill>
-                <a:latin typeface="Inter"/>
-              </a:rPr>
-              <a:t>•  small-cell rule and opt-outs enforced inside the query</a:t>
-            </a:r>
-          </a:p>
-          <a:p>
-            <a:pPr>
-              <a:spcAft>
-                <a:spcPts val="800"/>
-              </a:spcAft>
-            </a:pPr>
-            <a:r>
-              <a:rPr sz="1500" b="1">
-                <a:solidFill>
-                  <a:srgbClr val="1F2A37"/>
-                </a:solidFill>
-                <a:latin typeface="Inter"/>
-              </a:rPr>
-              <a:t>•  records only in a secure room: images, no download, audit log</a:t>
-            </a:r>
-          </a:p>
-        </p:txBody>
-      </p:sp>
-      <p:sp>
-        <p:nvSpPr>
-          <p:cNvPr id="15" name="Rounded Rectangle 14"/>
+          <p:cNvPr id="19" name="Rounded Rectangle 18"/>
           <p:cNvSpPr/>
           <p:nvPr/>
         </p:nvSpPr>
         <p:spPr>
           <a:xfrm>
-            <a:off x="548640" y="5212080"/>
-            <a:ext cx="11064240" cy="914400"/>
+            <a:off x="6263640" y="3794760"/>
+            <a:ext cx="164592" cy="2103120"/>
           </a:xfrm>
           <a:prstGeom prst="roundRect">
             <a:avLst>
@@ -5499,7 +5577,7 @@
             </a:avLst>
           </a:prstGeom>
           <a:solidFill>
-            <a:srgbClr val="1F3A5F"/>
+            <a:srgbClr val="C62828"/>
           </a:solidFill>
           <a:ln>
             <a:noFill/>
@@ -5530,14 +5608,14 @@
       </p:sp>
       <p:sp>
         <p:nvSpPr>
-          <p:cNvPr id="16" name="TextBox 15"/>
+          <p:cNvPr id="20" name="TextBox 19"/>
           <p:cNvSpPr txBox="1"/>
           <p:nvPr/>
         </p:nvSpPr>
         <p:spPr>
           <a:xfrm>
-            <a:off x="822960" y="5212080"/>
-            <a:ext cx="10515600" cy="914400"/>
+            <a:off x="6720840" y="4206240"/>
+            <a:ext cx="4663440" cy="731520"/>
           </a:xfrm>
           <a:prstGeom prst="rect">
             <a:avLst/>
@@ -5545,27 +5623,62 @@
           <a:noFill/>
         </p:spPr>
         <p:txBody>
-          <a:bodyPr wrap="square" anchor="ctr" lIns="45720" rIns="45720">
+          <a:bodyPr wrap="square" anchor="t" lIns="45720" rIns="45720">
             <a:spAutoFit/>
           </a:bodyPr>
           <a:lstStyle/>
           <a:p>
             <a:pPr algn="l"/>
             <a:r>
-              <a:rPr sz="1800" b="1">
-                <a:solidFill>
-                  <a:srgbClr val="FFFFFF"/>
-                </a:solidFill>
-                <a:latin typeface="Inter"/>
-              </a:rPr>
-              <a:t>Decisions in seconds instead of weeks — every one of them explained, and identical on every run.</a:t>
-            </a:r>
-          </a:p>
-        </p:txBody>
-      </p:sp>
-      <p:sp>
-        <p:nvSpPr>
-          <p:cNvPr id="17" name="TextBox 16"/>
+              <a:rPr sz="2800" b="1">
+                <a:solidFill>
+                  <a:srgbClr val="C62828"/>
+                </a:solidFill>
+                <a:latin typeface="Inter"/>
+              </a:rPr>
+              <a:t>Secure room, no exit</a:t>
+            </a:r>
+          </a:p>
+        </p:txBody>
+      </p:sp>
+      <p:sp>
+        <p:nvSpPr>
+          <p:cNvPr id="21" name="TextBox 20"/>
+          <p:cNvSpPr txBox="1"/>
+          <p:nvPr/>
+        </p:nvSpPr>
+        <p:spPr>
+          <a:xfrm>
+            <a:off x="6720840" y="4983480"/>
+            <a:ext cx="4663440" cy="548640"/>
+          </a:xfrm>
+          <a:prstGeom prst="rect">
+            <a:avLst/>
+          </a:prstGeom>
+          <a:noFill/>
+        </p:spPr>
+        <p:txBody>
+          <a:bodyPr wrap="square" anchor="t" lIns="45720" rIns="45720">
+            <a:spAutoFit/>
+          </a:bodyPr>
+          <a:lstStyle/>
+          <a:p>
+            <a:pPr algn="l"/>
+            <a:r>
+              <a:rPr sz="1700" b="0">
+                <a:solidFill>
+                  <a:srgbClr val="5B6472"/>
+                </a:solidFill>
+                <a:latin typeface="Inter"/>
+              </a:rPr>
+              <a:t>records viewed as images, never downloaded</a:t>
+            </a:r>
+          </a:p>
+        </p:txBody>
+      </p:sp>
+      <p:sp>
+        <p:nvSpPr>
+          <p:cNvPr id="22" name="TextBox 21"/>
           <p:cNvSpPr txBox="1"/>
           <p:nvPr/>
         </p:nvSpPr>

</xml_diff>